<commit_message>
Update: language switcher pill to LG red
</commit_message>
<xml_diff>
--- a/LG_Hanoi_AI_Story_Slide_Bilingual.pptx
+++ b/LG_Hanoi_AI_Story_Slide_Bilingual.pptx
@@ -130,7 +130,7 @@
           <p:cNvPr id="2" name="Title 1">
             <a:extLst>
               <a:ext uri="{FF2B5EF4-FFF2-40B4-BE49-F238E27FC236}">
-                <a16:creationId xmlns:a16="http://schemas.microsoft.com/office/drawing/2014/main" id="{221A89AE-CF4D-4B5F-B390-2CAAA9742382}"/>
+                <a16:creationId xmlns:a16="http://schemas.microsoft.com/office/drawing/2014/main" id="{C0F29553-AAD5-4518-9E78-61F6F4B56D44}"/>
               </a:ext>
             </a:extLst>
           </p:cNvPr>
@@ -167,7 +167,7 @@
           <p:cNvPr id="3" name="Subtitle 2">
             <a:extLst>
               <a:ext uri="{FF2B5EF4-FFF2-40B4-BE49-F238E27FC236}">
-                <a16:creationId xmlns:a16="http://schemas.microsoft.com/office/drawing/2014/main" id="{E310527A-B5CE-49B0-8525-BA40A3DA407C}"/>
+                <a16:creationId xmlns:a16="http://schemas.microsoft.com/office/drawing/2014/main" id="{25524C24-C82A-44E8-ACE6-C2E2B0B11049}"/>
               </a:ext>
             </a:extLst>
           </p:cNvPr>
@@ -237,7 +237,7 @@
           <p:cNvPr id="4" name="Date Placeholder 3">
             <a:extLst>
               <a:ext uri="{FF2B5EF4-FFF2-40B4-BE49-F238E27FC236}">
-                <a16:creationId xmlns:a16="http://schemas.microsoft.com/office/drawing/2014/main" id="{AE7B54B6-6647-4C76-981A-82CBCF97C2AD}"/>
+                <a16:creationId xmlns:a16="http://schemas.microsoft.com/office/drawing/2014/main" id="{AEB05A24-B6CA-4DD8-8FAE-789450ABDD3B}"/>
               </a:ext>
             </a:extLst>
           </p:cNvPr>
@@ -253,7 +253,7 @@
           <a:bodyPr/>
           <a:lstStyle/>
           <a:p>
-            <a:fld id="{73F7D07F-1C37-4603-8754-37B1FBD73B55}" type="datetimeFigureOut">
+            <a:fld id="{5DBD9EBB-3912-4816-B5AB-666E3FD080CD}" type="datetimeFigureOut">
               <a:rPr lang="en-US" smtClean="0"/>
               <a:t>8/14/2026</a:t>
             </a:fld>
@@ -266,7 +266,7 @@
           <p:cNvPr id="5" name="Footer Placeholder 4">
             <a:extLst>
               <a:ext uri="{FF2B5EF4-FFF2-40B4-BE49-F238E27FC236}">
-                <a16:creationId xmlns:a16="http://schemas.microsoft.com/office/drawing/2014/main" id="{2E554A2B-BD53-4081-9105-C61C9DA5E875}"/>
+                <a16:creationId xmlns:a16="http://schemas.microsoft.com/office/drawing/2014/main" id="{2DF123DB-1B36-491B-BD98-9533B980F18F}"/>
               </a:ext>
             </a:extLst>
           </p:cNvPr>
@@ -291,7 +291,7 @@
           <p:cNvPr id="6" name="Slide Number Placeholder 5">
             <a:extLst>
               <a:ext uri="{FF2B5EF4-FFF2-40B4-BE49-F238E27FC236}">
-                <a16:creationId xmlns:a16="http://schemas.microsoft.com/office/drawing/2014/main" id="{89D3B3A4-38E2-462B-9086-AE43FB30E87E}"/>
+                <a16:creationId xmlns:a16="http://schemas.microsoft.com/office/drawing/2014/main" id="{EDC129E1-720A-4062-8D42-D7CB25103B1A}"/>
               </a:ext>
             </a:extLst>
           </p:cNvPr>
@@ -307,7 +307,7 @@
           <a:bodyPr/>
           <a:lstStyle/>
           <a:p>
-            <a:fld id="{6DB29B5D-8960-46B2-B219-E18C7AD8C203}" type="slidenum">
+            <a:fld id="{4540F10B-E941-4DDC-AB99-3E9846EF7589}" type="slidenum">
               <a:rPr lang="en-US" smtClean="0"/>
               <a:t>‹#›</a:t>
             </a:fld>
@@ -318,7 +318,7 @@
     </p:spTree>
     <p:extLst>
       <p:ext uri="{BB962C8B-B14F-4D97-AF65-F5344CB8AC3E}">
-        <p14:creationId xmlns:p14="http://schemas.microsoft.com/office/powerpoint/2010/main" val="1539850548"/>
+        <p14:creationId xmlns:p14="http://schemas.microsoft.com/office/powerpoint/2010/main" val="1945740203"/>
       </p:ext>
     </p:extLst>
   </p:cSld>
@@ -350,7 +350,7 @@
           <p:cNvPr id="2" name="Title 1">
             <a:extLst>
               <a:ext uri="{FF2B5EF4-FFF2-40B4-BE49-F238E27FC236}">
-                <a16:creationId xmlns:a16="http://schemas.microsoft.com/office/drawing/2014/main" id="{371085D4-274B-4616-9AFD-4BAB2018686C}"/>
+                <a16:creationId xmlns:a16="http://schemas.microsoft.com/office/drawing/2014/main" id="{242BFA01-0FB8-4311-8A08-856F617355FC}"/>
               </a:ext>
             </a:extLst>
           </p:cNvPr>
@@ -378,7 +378,7 @@
           <p:cNvPr id="3" name="Vertical Text Placeholder 2">
             <a:extLst>
               <a:ext uri="{FF2B5EF4-FFF2-40B4-BE49-F238E27FC236}">
-                <a16:creationId xmlns:a16="http://schemas.microsoft.com/office/drawing/2014/main" id="{AADF8769-BD32-4A2E-ADD9-1BA927C0B94E}"/>
+                <a16:creationId xmlns:a16="http://schemas.microsoft.com/office/drawing/2014/main" id="{FC3C67CB-FDAC-4406-8EB6-CD1BD6696FAA}"/>
               </a:ext>
             </a:extLst>
           </p:cNvPr>
@@ -435,7 +435,7 @@
           <p:cNvPr id="4" name="Date Placeholder 3">
             <a:extLst>
               <a:ext uri="{FF2B5EF4-FFF2-40B4-BE49-F238E27FC236}">
-                <a16:creationId xmlns:a16="http://schemas.microsoft.com/office/drawing/2014/main" id="{9D610034-71D7-4A69-9E67-C775FAAFAC35}"/>
+                <a16:creationId xmlns:a16="http://schemas.microsoft.com/office/drawing/2014/main" id="{E00DD0E7-59A8-473D-94FA-8B4E222FC2F5}"/>
               </a:ext>
             </a:extLst>
           </p:cNvPr>
@@ -451,7 +451,7 @@
           <a:bodyPr/>
           <a:lstStyle/>
           <a:p>
-            <a:fld id="{73F7D07F-1C37-4603-8754-37B1FBD73B55}" type="datetimeFigureOut">
+            <a:fld id="{5DBD9EBB-3912-4816-B5AB-666E3FD080CD}" type="datetimeFigureOut">
               <a:rPr lang="en-US" smtClean="0"/>
               <a:t>8/14/2026</a:t>
             </a:fld>
@@ -464,7 +464,7 @@
           <p:cNvPr id="5" name="Footer Placeholder 4">
             <a:extLst>
               <a:ext uri="{FF2B5EF4-FFF2-40B4-BE49-F238E27FC236}">
-                <a16:creationId xmlns:a16="http://schemas.microsoft.com/office/drawing/2014/main" id="{15AF6F1D-3F87-4B96-A704-5DEE6B4A3534}"/>
+                <a16:creationId xmlns:a16="http://schemas.microsoft.com/office/drawing/2014/main" id="{B2B99EE0-5DB1-4616-87F3-D2F4CBE59EC3}"/>
               </a:ext>
             </a:extLst>
           </p:cNvPr>
@@ -489,7 +489,7 @@
           <p:cNvPr id="6" name="Slide Number Placeholder 5">
             <a:extLst>
               <a:ext uri="{FF2B5EF4-FFF2-40B4-BE49-F238E27FC236}">
-                <a16:creationId xmlns:a16="http://schemas.microsoft.com/office/drawing/2014/main" id="{12F32DBA-FB6D-4FA5-A7E5-88177BEA9D63}"/>
+                <a16:creationId xmlns:a16="http://schemas.microsoft.com/office/drawing/2014/main" id="{E45E2875-4209-4929-AA4C-BA185DB92373}"/>
               </a:ext>
             </a:extLst>
           </p:cNvPr>
@@ -505,7 +505,7 @@
           <a:bodyPr/>
           <a:lstStyle/>
           <a:p>
-            <a:fld id="{6DB29B5D-8960-46B2-B219-E18C7AD8C203}" type="slidenum">
+            <a:fld id="{4540F10B-E941-4DDC-AB99-3E9846EF7589}" type="slidenum">
               <a:rPr lang="en-US" smtClean="0"/>
               <a:t>‹#›</a:t>
             </a:fld>
@@ -516,7 +516,7 @@
     </p:spTree>
     <p:extLst>
       <p:ext uri="{BB962C8B-B14F-4D97-AF65-F5344CB8AC3E}">
-        <p14:creationId xmlns:p14="http://schemas.microsoft.com/office/powerpoint/2010/main" val="3307055791"/>
+        <p14:creationId xmlns:p14="http://schemas.microsoft.com/office/powerpoint/2010/main" val="4054293008"/>
       </p:ext>
     </p:extLst>
   </p:cSld>
@@ -548,7 +548,7 @@
           <p:cNvPr id="2" name="Vertical Title 1">
             <a:extLst>
               <a:ext uri="{FF2B5EF4-FFF2-40B4-BE49-F238E27FC236}">
-                <a16:creationId xmlns:a16="http://schemas.microsoft.com/office/drawing/2014/main" id="{6C8F3449-77CC-41CB-A2BF-86B9B4CC5EF9}"/>
+                <a16:creationId xmlns:a16="http://schemas.microsoft.com/office/drawing/2014/main" id="{9FEB3A30-EFCE-4004-AB36-A35F9610FF95}"/>
               </a:ext>
             </a:extLst>
           </p:cNvPr>
@@ -581,7 +581,7 @@
           <p:cNvPr id="3" name="Vertical Text Placeholder 2">
             <a:extLst>
               <a:ext uri="{FF2B5EF4-FFF2-40B4-BE49-F238E27FC236}">
-                <a16:creationId xmlns:a16="http://schemas.microsoft.com/office/drawing/2014/main" id="{464BB690-3D07-4E65-BAF0-53D46BA8B944}"/>
+                <a16:creationId xmlns:a16="http://schemas.microsoft.com/office/drawing/2014/main" id="{4455A633-C333-4BF6-A6C8-6C134243DF5B}"/>
               </a:ext>
             </a:extLst>
           </p:cNvPr>
@@ -643,7 +643,7 @@
           <p:cNvPr id="4" name="Date Placeholder 3">
             <a:extLst>
               <a:ext uri="{FF2B5EF4-FFF2-40B4-BE49-F238E27FC236}">
-                <a16:creationId xmlns:a16="http://schemas.microsoft.com/office/drawing/2014/main" id="{C5A9909A-35C7-437F-BCC0-C3E69F9D29F8}"/>
+                <a16:creationId xmlns:a16="http://schemas.microsoft.com/office/drawing/2014/main" id="{5269BA06-2EB2-456A-AB03-A68896AB32FA}"/>
               </a:ext>
             </a:extLst>
           </p:cNvPr>
@@ -659,7 +659,7 @@
           <a:bodyPr/>
           <a:lstStyle/>
           <a:p>
-            <a:fld id="{73F7D07F-1C37-4603-8754-37B1FBD73B55}" type="datetimeFigureOut">
+            <a:fld id="{5DBD9EBB-3912-4816-B5AB-666E3FD080CD}" type="datetimeFigureOut">
               <a:rPr lang="en-US" smtClean="0"/>
               <a:t>8/14/2026</a:t>
             </a:fld>
@@ -672,7 +672,7 @@
           <p:cNvPr id="5" name="Footer Placeholder 4">
             <a:extLst>
               <a:ext uri="{FF2B5EF4-FFF2-40B4-BE49-F238E27FC236}">
-                <a16:creationId xmlns:a16="http://schemas.microsoft.com/office/drawing/2014/main" id="{2F4B4B26-B656-4B49-A6F2-17154BAF7360}"/>
+                <a16:creationId xmlns:a16="http://schemas.microsoft.com/office/drawing/2014/main" id="{EB09847F-DD52-4C52-8B51-E9FFC5E2CF87}"/>
               </a:ext>
             </a:extLst>
           </p:cNvPr>
@@ -697,7 +697,7 @@
           <p:cNvPr id="6" name="Slide Number Placeholder 5">
             <a:extLst>
               <a:ext uri="{FF2B5EF4-FFF2-40B4-BE49-F238E27FC236}">
-                <a16:creationId xmlns:a16="http://schemas.microsoft.com/office/drawing/2014/main" id="{B278AAA3-F6CD-4D85-A200-C229963613B7}"/>
+                <a16:creationId xmlns:a16="http://schemas.microsoft.com/office/drawing/2014/main" id="{62957247-B6EB-4B5E-9F3F-66E6F0150C06}"/>
               </a:ext>
             </a:extLst>
           </p:cNvPr>
@@ -713,7 +713,7 @@
           <a:bodyPr/>
           <a:lstStyle/>
           <a:p>
-            <a:fld id="{6DB29B5D-8960-46B2-B219-E18C7AD8C203}" type="slidenum">
+            <a:fld id="{4540F10B-E941-4DDC-AB99-3E9846EF7589}" type="slidenum">
               <a:rPr lang="en-US" smtClean="0"/>
               <a:t>‹#›</a:t>
             </a:fld>
@@ -724,7 +724,7 @@
     </p:spTree>
     <p:extLst>
       <p:ext uri="{BB962C8B-B14F-4D97-AF65-F5344CB8AC3E}">
-        <p14:creationId xmlns:p14="http://schemas.microsoft.com/office/powerpoint/2010/main" val="2061819126"/>
+        <p14:creationId xmlns:p14="http://schemas.microsoft.com/office/powerpoint/2010/main" val="3741088472"/>
       </p:ext>
     </p:extLst>
   </p:cSld>
@@ -756,7 +756,7 @@
           <p:cNvPr id="2" name="Title 1">
             <a:extLst>
               <a:ext uri="{FF2B5EF4-FFF2-40B4-BE49-F238E27FC236}">
-                <a16:creationId xmlns:a16="http://schemas.microsoft.com/office/drawing/2014/main" id="{3BDE5CD7-B35B-45A0-A387-8EE362D25505}"/>
+                <a16:creationId xmlns:a16="http://schemas.microsoft.com/office/drawing/2014/main" id="{28A3D43D-CF82-4350-A61A-B7C2969BA0B9}"/>
               </a:ext>
             </a:extLst>
           </p:cNvPr>
@@ -784,7 +784,7 @@
           <p:cNvPr id="3" name="Content Placeholder 2">
             <a:extLst>
               <a:ext uri="{FF2B5EF4-FFF2-40B4-BE49-F238E27FC236}">
-                <a16:creationId xmlns:a16="http://schemas.microsoft.com/office/drawing/2014/main" id="{82877B48-D001-4931-975D-FA12D5D35B36}"/>
+                <a16:creationId xmlns:a16="http://schemas.microsoft.com/office/drawing/2014/main" id="{73D5884D-F36C-44C7-AE36-AD44E6BFE8A2}"/>
               </a:ext>
             </a:extLst>
           </p:cNvPr>
@@ -841,7 +841,7 @@
           <p:cNvPr id="4" name="Date Placeholder 3">
             <a:extLst>
               <a:ext uri="{FF2B5EF4-FFF2-40B4-BE49-F238E27FC236}">
-                <a16:creationId xmlns:a16="http://schemas.microsoft.com/office/drawing/2014/main" id="{320E3413-DB2E-45A3-B7FA-5EDBEFA6BDCD}"/>
+                <a16:creationId xmlns:a16="http://schemas.microsoft.com/office/drawing/2014/main" id="{F3E15C0F-4DA0-4D42-A5D6-E8329D59F972}"/>
               </a:ext>
             </a:extLst>
           </p:cNvPr>
@@ -857,7 +857,7 @@
           <a:bodyPr/>
           <a:lstStyle/>
           <a:p>
-            <a:fld id="{73F7D07F-1C37-4603-8754-37B1FBD73B55}" type="datetimeFigureOut">
+            <a:fld id="{5DBD9EBB-3912-4816-B5AB-666E3FD080CD}" type="datetimeFigureOut">
               <a:rPr lang="en-US" smtClean="0"/>
               <a:t>8/14/2026</a:t>
             </a:fld>
@@ -870,7 +870,7 @@
           <p:cNvPr id="5" name="Footer Placeholder 4">
             <a:extLst>
               <a:ext uri="{FF2B5EF4-FFF2-40B4-BE49-F238E27FC236}">
-                <a16:creationId xmlns:a16="http://schemas.microsoft.com/office/drawing/2014/main" id="{0620CB60-C65C-438D-8836-9058312D8DE2}"/>
+                <a16:creationId xmlns:a16="http://schemas.microsoft.com/office/drawing/2014/main" id="{034DB339-2917-4F31-9EA8-3ED965CAC028}"/>
               </a:ext>
             </a:extLst>
           </p:cNvPr>
@@ -895,7 +895,7 @@
           <p:cNvPr id="6" name="Slide Number Placeholder 5">
             <a:extLst>
               <a:ext uri="{FF2B5EF4-FFF2-40B4-BE49-F238E27FC236}">
-                <a16:creationId xmlns:a16="http://schemas.microsoft.com/office/drawing/2014/main" id="{0CB9836B-4CC3-4631-984C-22F07C7910BE}"/>
+                <a16:creationId xmlns:a16="http://schemas.microsoft.com/office/drawing/2014/main" id="{50303D0F-F90D-4489-9974-825AAEE9CB25}"/>
               </a:ext>
             </a:extLst>
           </p:cNvPr>
@@ -911,7 +911,7 @@
           <a:bodyPr/>
           <a:lstStyle/>
           <a:p>
-            <a:fld id="{6DB29B5D-8960-46B2-B219-E18C7AD8C203}" type="slidenum">
+            <a:fld id="{4540F10B-E941-4DDC-AB99-3E9846EF7589}" type="slidenum">
               <a:rPr lang="en-US" smtClean="0"/>
               <a:t>‹#›</a:t>
             </a:fld>
@@ -922,7 +922,7 @@
     </p:spTree>
     <p:extLst>
       <p:ext uri="{BB962C8B-B14F-4D97-AF65-F5344CB8AC3E}">
-        <p14:creationId xmlns:p14="http://schemas.microsoft.com/office/powerpoint/2010/main" val="3947750118"/>
+        <p14:creationId xmlns:p14="http://schemas.microsoft.com/office/powerpoint/2010/main" val="2452905679"/>
       </p:ext>
     </p:extLst>
   </p:cSld>
@@ -954,7 +954,7 @@
           <p:cNvPr id="2" name="Title 1">
             <a:extLst>
               <a:ext uri="{FF2B5EF4-FFF2-40B4-BE49-F238E27FC236}">
-                <a16:creationId xmlns:a16="http://schemas.microsoft.com/office/drawing/2014/main" id="{6D61914A-BE39-4CB8-AD69-A11BE7769016}"/>
+                <a16:creationId xmlns:a16="http://schemas.microsoft.com/office/drawing/2014/main" id="{0504881A-5452-44EE-A6B5-7286B0751F72}"/>
               </a:ext>
             </a:extLst>
           </p:cNvPr>
@@ -991,7 +991,7 @@
           <p:cNvPr id="3" name="Text Placeholder 2">
             <a:extLst>
               <a:ext uri="{FF2B5EF4-FFF2-40B4-BE49-F238E27FC236}">
-                <a16:creationId xmlns:a16="http://schemas.microsoft.com/office/drawing/2014/main" id="{0C924EA2-76BD-42E4-AF76-03828A5D367A}"/>
+                <a16:creationId xmlns:a16="http://schemas.microsoft.com/office/drawing/2014/main" id="{86633C4E-D71F-4C2C-9F02-53750B1C15E0}"/>
               </a:ext>
             </a:extLst>
           </p:cNvPr>
@@ -1116,7 +1116,7 @@
           <p:cNvPr id="4" name="Date Placeholder 3">
             <a:extLst>
               <a:ext uri="{FF2B5EF4-FFF2-40B4-BE49-F238E27FC236}">
-                <a16:creationId xmlns:a16="http://schemas.microsoft.com/office/drawing/2014/main" id="{65EDD2E3-9F40-4553-8CC8-B45F058908F8}"/>
+                <a16:creationId xmlns:a16="http://schemas.microsoft.com/office/drawing/2014/main" id="{6A6D7DB3-1935-492F-AC07-1F8FDC155B15}"/>
               </a:ext>
             </a:extLst>
           </p:cNvPr>
@@ -1132,7 +1132,7 @@
           <a:bodyPr/>
           <a:lstStyle/>
           <a:p>
-            <a:fld id="{73F7D07F-1C37-4603-8754-37B1FBD73B55}" type="datetimeFigureOut">
+            <a:fld id="{5DBD9EBB-3912-4816-B5AB-666E3FD080CD}" type="datetimeFigureOut">
               <a:rPr lang="en-US" smtClean="0"/>
               <a:t>8/14/2026</a:t>
             </a:fld>
@@ -1145,7 +1145,7 @@
           <p:cNvPr id="5" name="Footer Placeholder 4">
             <a:extLst>
               <a:ext uri="{FF2B5EF4-FFF2-40B4-BE49-F238E27FC236}">
-                <a16:creationId xmlns:a16="http://schemas.microsoft.com/office/drawing/2014/main" id="{38BF4FA5-7191-4D19-A7B1-B3B3E03BAEB0}"/>
+                <a16:creationId xmlns:a16="http://schemas.microsoft.com/office/drawing/2014/main" id="{5ACECD15-955F-4369-9663-797F41DD468D}"/>
               </a:ext>
             </a:extLst>
           </p:cNvPr>
@@ -1170,7 +1170,7 @@
           <p:cNvPr id="6" name="Slide Number Placeholder 5">
             <a:extLst>
               <a:ext uri="{FF2B5EF4-FFF2-40B4-BE49-F238E27FC236}">
-                <a16:creationId xmlns:a16="http://schemas.microsoft.com/office/drawing/2014/main" id="{EC14E21D-EF52-4ED7-9EB9-831077F5102A}"/>
+                <a16:creationId xmlns:a16="http://schemas.microsoft.com/office/drawing/2014/main" id="{B7F6509F-6D93-41FF-8A21-3DA09FA0A6BC}"/>
               </a:ext>
             </a:extLst>
           </p:cNvPr>
@@ -1186,7 +1186,7 @@
           <a:bodyPr/>
           <a:lstStyle/>
           <a:p>
-            <a:fld id="{6DB29B5D-8960-46B2-B219-E18C7AD8C203}" type="slidenum">
+            <a:fld id="{4540F10B-E941-4DDC-AB99-3E9846EF7589}" type="slidenum">
               <a:rPr lang="en-US" smtClean="0"/>
               <a:t>‹#›</a:t>
             </a:fld>
@@ -1197,7 +1197,7 @@
     </p:spTree>
     <p:extLst>
       <p:ext uri="{BB962C8B-B14F-4D97-AF65-F5344CB8AC3E}">
-        <p14:creationId xmlns:p14="http://schemas.microsoft.com/office/powerpoint/2010/main" val="3921034388"/>
+        <p14:creationId xmlns:p14="http://schemas.microsoft.com/office/powerpoint/2010/main" val="999486930"/>
       </p:ext>
     </p:extLst>
   </p:cSld>
@@ -1229,7 +1229,7 @@
           <p:cNvPr id="2" name="Title 1">
             <a:extLst>
               <a:ext uri="{FF2B5EF4-FFF2-40B4-BE49-F238E27FC236}">
-                <a16:creationId xmlns:a16="http://schemas.microsoft.com/office/drawing/2014/main" id="{1CEC01DC-5CAD-4EFB-9271-1D5BFE1A9B7A}"/>
+                <a16:creationId xmlns:a16="http://schemas.microsoft.com/office/drawing/2014/main" id="{655C08B0-D274-44D0-982C-9BD7E2EC112E}"/>
               </a:ext>
             </a:extLst>
           </p:cNvPr>
@@ -1257,7 +1257,7 @@
           <p:cNvPr id="3" name="Content Placeholder 2">
             <a:extLst>
               <a:ext uri="{FF2B5EF4-FFF2-40B4-BE49-F238E27FC236}">
-                <a16:creationId xmlns:a16="http://schemas.microsoft.com/office/drawing/2014/main" id="{3F4C9694-A316-4CC9-8677-7D1490256E86}"/>
+                <a16:creationId xmlns:a16="http://schemas.microsoft.com/office/drawing/2014/main" id="{473FED64-5D3A-4F4D-84B7-B89021B5A0FA}"/>
               </a:ext>
             </a:extLst>
           </p:cNvPr>
@@ -1319,7 +1319,7 @@
           <p:cNvPr id="4" name="Content Placeholder 3">
             <a:extLst>
               <a:ext uri="{FF2B5EF4-FFF2-40B4-BE49-F238E27FC236}">
-                <a16:creationId xmlns:a16="http://schemas.microsoft.com/office/drawing/2014/main" id="{FBAA792B-B51C-4411-8CD6-28EB787808F5}"/>
+                <a16:creationId xmlns:a16="http://schemas.microsoft.com/office/drawing/2014/main" id="{4429087C-C759-44B4-A624-EA12B07ACF2C}"/>
               </a:ext>
             </a:extLst>
           </p:cNvPr>
@@ -1381,7 +1381,7 @@
           <p:cNvPr id="5" name="Date Placeholder 4">
             <a:extLst>
               <a:ext uri="{FF2B5EF4-FFF2-40B4-BE49-F238E27FC236}">
-                <a16:creationId xmlns:a16="http://schemas.microsoft.com/office/drawing/2014/main" id="{442FD7C6-054A-4322-9152-CB8E4D60D467}"/>
+                <a16:creationId xmlns:a16="http://schemas.microsoft.com/office/drawing/2014/main" id="{954EB824-2791-4387-AF76-E39D7910EAD4}"/>
               </a:ext>
             </a:extLst>
           </p:cNvPr>
@@ -1397,7 +1397,7 @@
           <a:bodyPr/>
           <a:lstStyle/>
           <a:p>
-            <a:fld id="{73F7D07F-1C37-4603-8754-37B1FBD73B55}" type="datetimeFigureOut">
+            <a:fld id="{5DBD9EBB-3912-4816-B5AB-666E3FD080CD}" type="datetimeFigureOut">
               <a:rPr lang="en-US" smtClean="0"/>
               <a:t>8/14/2026</a:t>
             </a:fld>
@@ -1410,7 +1410,7 @@
           <p:cNvPr id="6" name="Footer Placeholder 5">
             <a:extLst>
               <a:ext uri="{FF2B5EF4-FFF2-40B4-BE49-F238E27FC236}">
-                <a16:creationId xmlns:a16="http://schemas.microsoft.com/office/drawing/2014/main" id="{5EB07B88-E045-47EF-B1A7-EAAE184A498E}"/>
+                <a16:creationId xmlns:a16="http://schemas.microsoft.com/office/drawing/2014/main" id="{5641DF92-6007-4E5E-A550-1914715412AD}"/>
               </a:ext>
             </a:extLst>
           </p:cNvPr>
@@ -1435,7 +1435,7 @@
           <p:cNvPr id="7" name="Slide Number Placeholder 6">
             <a:extLst>
               <a:ext uri="{FF2B5EF4-FFF2-40B4-BE49-F238E27FC236}">
-                <a16:creationId xmlns:a16="http://schemas.microsoft.com/office/drawing/2014/main" id="{502A6DE9-7E27-4EC4-9568-193DC0C7682E}"/>
+                <a16:creationId xmlns:a16="http://schemas.microsoft.com/office/drawing/2014/main" id="{41965B5B-97CE-40AE-8747-4365ECDBF28B}"/>
               </a:ext>
             </a:extLst>
           </p:cNvPr>
@@ -1451,7 +1451,7 @@
           <a:bodyPr/>
           <a:lstStyle/>
           <a:p>
-            <a:fld id="{6DB29B5D-8960-46B2-B219-E18C7AD8C203}" type="slidenum">
+            <a:fld id="{4540F10B-E941-4DDC-AB99-3E9846EF7589}" type="slidenum">
               <a:rPr lang="en-US" smtClean="0"/>
               <a:t>‹#›</a:t>
             </a:fld>
@@ -1462,7 +1462,7 @@
     </p:spTree>
     <p:extLst>
       <p:ext uri="{BB962C8B-B14F-4D97-AF65-F5344CB8AC3E}">
-        <p14:creationId xmlns:p14="http://schemas.microsoft.com/office/powerpoint/2010/main" val="1095901594"/>
+        <p14:creationId xmlns:p14="http://schemas.microsoft.com/office/powerpoint/2010/main" val="1368658982"/>
       </p:ext>
     </p:extLst>
   </p:cSld>
@@ -1494,7 +1494,7 @@
           <p:cNvPr id="2" name="Title 1">
             <a:extLst>
               <a:ext uri="{FF2B5EF4-FFF2-40B4-BE49-F238E27FC236}">
-                <a16:creationId xmlns:a16="http://schemas.microsoft.com/office/drawing/2014/main" id="{ED2C3732-C56D-42A1-B6E3-ECAA1E2DB2F1}"/>
+                <a16:creationId xmlns:a16="http://schemas.microsoft.com/office/drawing/2014/main" id="{ED6338C6-64E9-45D2-AD8F-944C548B1952}"/>
               </a:ext>
             </a:extLst>
           </p:cNvPr>
@@ -1527,7 +1527,7 @@
           <p:cNvPr id="3" name="Text Placeholder 2">
             <a:extLst>
               <a:ext uri="{FF2B5EF4-FFF2-40B4-BE49-F238E27FC236}">
-                <a16:creationId xmlns:a16="http://schemas.microsoft.com/office/drawing/2014/main" id="{702AC0DC-ED10-4D79-A96E-593339D005F6}"/>
+                <a16:creationId xmlns:a16="http://schemas.microsoft.com/office/drawing/2014/main" id="{8F6B972E-A714-4396-B2CD-E02C3EC80CBD}"/>
               </a:ext>
             </a:extLst>
           </p:cNvPr>
@@ -1598,7 +1598,7 @@
           <p:cNvPr id="4" name="Content Placeholder 3">
             <a:extLst>
               <a:ext uri="{FF2B5EF4-FFF2-40B4-BE49-F238E27FC236}">
-                <a16:creationId xmlns:a16="http://schemas.microsoft.com/office/drawing/2014/main" id="{418BD6A0-D872-4FE7-AAE6-7723C42F41ED}"/>
+                <a16:creationId xmlns:a16="http://schemas.microsoft.com/office/drawing/2014/main" id="{4F3B2E7E-3379-4BDB-A8D3-56EB4B389EB6}"/>
               </a:ext>
             </a:extLst>
           </p:cNvPr>
@@ -1660,7 +1660,7 @@
           <p:cNvPr id="5" name="Text Placeholder 4">
             <a:extLst>
               <a:ext uri="{FF2B5EF4-FFF2-40B4-BE49-F238E27FC236}">
-                <a16:creationId xmlns:a16="http://schemas.microsoft.com/office/drawing/2014/main" id="{FF59369B-3589-4878-89B8-A830325723AD}"/>
+                <a16:creationId xmlns:a16="http://schemas.microsoft.com/office/drawing/2014/main" id="{151D1B37-0B8C-4860-9CE3-C0B213DA6474}"/>
               </a:ext>
             </a:extLst>
           </p:cNvPr>
@@ -1731,7 +1731,7 @@
           <p:cNvPr id="6" name="Content Placeholder 5">
             <a:extLst>
               <a:ext uri="{FF2B5EF4-FFF2-40B4-BE49-F238E27FC236}">
-                <a16:creationId xmlns:a16="http://schemas.microsoft.com/office/drawing/2014/main" id="{0756364E-5CF5-4F17-86A4-5A768B5C9289}"/>
+                <a16:creationId xmlns:a16="http://schemas.microsoft.com/office/drawing/2014/main" id="{8CF86320-8E99-4129-B85A-21839D22CE0B}"/>
               </a:ext>
             </a:extLst>
           </p:cNvPr>
@@ -1793,7 +1793,7 @@
           <p:cNvPr id="7" name="Date Placeholder 6">
             <a:extLst>
               <a:ext uri="{FF2B5EF4-FFF2-40B4-BE49-F238E27FC236}">
-                <a16:creationId xmlns:a16="http://schemas.microsoft.com/office/drawing/2014/main" id="{3ED2B303-E0E6-4CD8-A970-7EFB3F2C66DD}"/>
+                <a16:creationId xmlns:a16="http://schemas.microsoft.com/office/drawing/2014/main" id="{CBC3112D-D27C-4857-BA67-17903399465D}"/>
               </a:ext>
             </a:extLst>
           </p:cNvPr>
@@ -1809,7 +1809,7 @@
           <a:bodyPr/>
           <a:lstStyle/>
           <a:p>
-            <a:fld id="{73F7D07F-1C37-4603-8754-37B1FBD73B55}" type="datetimeFigureOut">
+            <a:fld id="{5DBD9EBB-3912-4816-B5AB-666E3FD080CD}" type="datetimeFigureOut">
               <a:rPr lang="en-US" smtClean="0"/>
               <a:t>8/14/2026</a:t>
             </a:fld>
@@ -1822,7 +1822,7 @@
           <p:cNvPr id="8" name="Footer Placeholder 7">
             <a:extLst>
               <a:ext uri="{FF2B5EF4-FFF2-40B4-BE49-F238E27FC236}">
-                <a16:creationId xmlns:a16="http://schemas.microsoft.com/office/drawing/2014/main" id="{49968E30-8B04-4BB8-9C06-32958FBB4382}"/>
+                <a16:creationId xmlns:a16="http://schemas.microsoft.com/office/drawing/2014/main" id="{CFE8D43E-0E93-42D9-8494-3B40387C52E0}"/>
               </a:ext>
             </a:extLst>
           </p:cNvPr>
@@ -1847,7 +1847,7 @@
           <p:cNvPr id="9" name="Slide Number Placeholder 8">
             <a:extLst>
               <a:ext uri="{FF2B5EF4-FFF2-40B4-BE49-F238E27FC236}">
-                <a16:creationId xmlns:a16="http://schemas.microsoft.com/office/drawing/2014/main" id="{D3B8BD33-5E1B-4E10-91D1-755C66E9B977}"/>
+                <a16:creationId xmlns:a16="http://schemas.microsoft.com/office/drawing/2014/main" id="{89E4F2BE-B207-41EA-9BB1-9A438DFAEB0A}"/>
               </a:ext>
             </a:extLst>
           </p:cNvPr>
@@ -1863,7 +1863,7 @@
           <a:bodyPr/>
           <a:lstStyle/>
           <a:p>
-            <a:fld id="{6DB29B5D-8960-46B2-B219-E18C7AD8C203}" type="slidenum">
+            <a:fld id="{4540F10B-E941-4DDC-AB99-3E9846EF7589}" type="slidenum">
               <a:rPr lang="en-US" smtClean="0"/>
               <a:t>‹#›</a:t>
             </a:fld>
@@ -1874,7 +1874,7 @@
     </p:spTree>
     <p:extLst>
       <p:ext uri="{BB962C8B-B14F-4D97-AF65-F5344CB8AC3E}">
-        <p14:creationId xmlns:p14="http://schemas.microsoft.com/office/powerpoint/2010/main" val="2713076292"/>
+        <p14:creationId xmlns:p14="http://schemas.microsoft.com/office/powerpoint/2010/main" val="540561201"/>
       </p:ext>
     </p:extLst>
   </p:cSld>
@@ -1906,7 +1906,7 @@
           <p:cNvPr id="2" name="Title 1">
             <a:extLst>
               <a:ext uri="{FF2B5EF4-FFF2-40B4-BE49-F238E27FC236}">
-                <a16:creationId xmlns:a16="http://schemas.microsoft.com/office/drawing/2014/main" id="{0901A06D-3A75-42A5-BCF4-1AFC1DD3B8D2}"/>
+                <a16:creationId xmlns:a16="http://schemas.microsoft.com/office/drawing/2014/main" id="{65B6F8D0-14C0-4D23-BC2B-A21F7979DE61}"/>
               </a:ext>
             </a:extLst>
           </p:cNvPr>
@@ -1934,7 +1934,7 @@
           <p:cNvPr id="3" name="Date Placeholder 2">
             <a:extLst>
               <a:ext uri="{FF2B5EF4-FFF2-40B4-BE49-F238E27FC236}">
-                <a16:creationId xmlns:a16="http://schemas.microsoft.com/office/drawing/2014/main" id="{95415A8F-BEF7-4E8A-B74E-6DEEC8BBD3EA}"/>
+                <a16:creationId xmlns:a16="http://schemas.microsoft.com/office/drawing/2014/main" id="{38DEB686-2B9E-42B7-8DB3-D44DD7D574CE}"/>
               </a:ext>
             </a:extLst>
           </p:cNvPr>
@@ -1950,7 +1950,7 @@
           <a:bodyPr/>
           <a:lstStyle/>
           <a:p>
-            <a:fld id="{73F7D07F-1C37-4603-8754-37B1FBD73B55}" type="datetimeFigureOut">
+            <a:fld id="{5DBD9EBB-3912-4816-B5AB-666E3FD080CD}" type="datetimeFigureOut">
               <a:rPr lang="en-US" smtClean="0"/>
               <a:t>8/14/2026</a:t>
             </a:fld>
@@ -1963,7 +1963,7 @@
           <p:cNvPr id="4" name="Footer Placeholder 3">
             <a:extLst>
               <a:ext uri="{FF2B5EF4-FFF2-40B4-BE49-F238E27FC236}">
-                <a16:creationId xmlns:a16="http://schemas.microsoft.com/office/drawing/2014/main" id="{E9804137-BF53-457B-B2F5-7A1B80931F89}"/>
+                <a16:creationId xmlns:a16="http://schemas.microsoft.com/office/drawing/2014/main" id="{BAC78D0F-EE19-4BB7-B704-D3FFCBAFF254}"/>
               </a:ext>
             </a:extLst>
           </p:cNvPr>
@@ -1988,7 +1988,7 @@
           <p:cNvPr id="5" name="Slide Number Placeholder 4">
             <a:extLst>
               <a:ext uri="{FF2B5EF4-FFF2-40B4-BE49-F238E27FC236}">
-                <a16:creationId xmlns:a16="http://schemas.microsoft.com/office/drawing/2014/main" id="{2B86D60D-6FA2-4734-A588-DD57435FB3C2}"/>
+                <a16:creationId xmlns:a16="http://schemas.microsoft.com/office/drawing/2014/main" id="{B9688398-BFED-4B7A-B9F7-384CC1B58DDD}"/>
               </a:ext>
             </a:extLst>
           </p:cNvPr>
@@ -2004,7 +2004,7 @@
           <a:bodyPr/>
           <a:lstStyle/>
           <a:p>
-            <a:fld id="{6DB29B5D-8960-46B2-B219-E18C7AD8C203}" type="slidenum">
+            <a:fld id="{4540F10B-E941-4DDC-AB99-3E9846EF7589}" type="slidenum">
               <a:rPr lang="en-US" smtClean="0"/>
               <a:t>‹#›</a:t>
             </a:fld>
@@ -2015,7 +2015,7 @@
     </p:spTree>
     <p:extLst>
       <p:ext uri="{BB962C8B-B14F-4D97-AF65-F5344CB8AC3E}">
-        <p14:creationId xmlns:p14="http://schemas.microsoft.com/office/powerpoint/2010/main" val="2127596186"/>
+        <p14:creationId xmlns:p14="http://schemas.microsoft.com/office/powerpoint/2010/main" val="1420418997"/>
       </p:ext>
     </p:extLst>
   </p:cSld>
@@ -2047,7 +2047,7 @@
           <p:cNvPr id="2" name="Date Placeholder 1">
             <a:extLst>
               <a:ext uri="{FF2B5EF4-FFF2-40B4-BE49-F238E27FC236}">
-                <a16:creationId xmlns:a16="http://schemas.microsoft.com/office/drawing/2014/main" id="{21F75D41-B54C-4D76-BC11-50CE7ED12571}"/>
+                <a16:creationId xmlns:a16="http://schemas.microsoft.com/office/drawing/2014/main" id="{5C7C89B0-E348-422C-9391-866BDF0B7D82}"/>
               </a:ext>
             </a:extLst>
           </p:cNvPr>
@@ -2063,7 +2063,7 @@
           <a:bodyPr/>
           <a:lstStyle/>
           <a:p>
-            <a:fld id="{73F7D07F-1C37-4603-8754-37B1FBD73B55}" type="datetimeFigureOut">
+            <a:fld id="{5DBD9EBB-3912-4816-B5AB-666E3FD080CD}" type="datetimeFigureOut">
               <a:rPr lang="en-US" smtClean="0"/>
               <a:t>8/14/2026</a:t>
             </a:fld>
@@ -2076,7 +2076,7 @@
           <p:cNvPr id="3" name="Footer Placeholder 2">
             <a:extLst>
               <a:ext uri="{FF2B5EF4-FFF2-40B4-BE49-F238E27FC236}">
-                <a16:creationId xmlns:a16="http://schemas.microsoft.com/office/drawing/2014/main" id="{C97760A2-5C7E-4A37-8EB4-4378CA883D25}"/>
+                <a16:creationId xmlns:a16="http://schemas.microsoft.com/office/drawing/2014/main" id="{CEBD8833-FA3C-41C6-A8B9-3E2A5F0F8190}"/>
               </a:ext>
             </a:extLst>
           </p:cNvPr>
@@ -2101,7 +2101,7 @@
           <p:cNvPr id="4" name="Slide Number Placeholder 3">
             <a:extLst>
               <a:ext uri="{FF2B5EF4-FFF2-40B4-BE49-F238E27FC236}">
-                <a16:creationId xmlns:a16="http://schemas.microsoft.com/office/drawing/2014/main" id="{417EB6D1-2B0D-49AC-937E-F5F019C4B0F5}"/>
+                <a16:creationId xmlns:a16="http://schemas.microsoft.com/office/drawing/2014/main" id="{C344B917-905C-47CB-AE85-BE6F36D46027}"/>
               </a:ext>
             </a:extLst>
           </p:cNvPr>
@@ -2117,7 +2117,7 @@
           <a:bodyPr/>
           <a:lstStyle/>
           <a:p>
-            <a:fld id="{6DB29B5D-8960-46B2-B219-E18C7AD8C203}" type="slidenum">
+            <a:fld id="{4540F10B-E941-4DDC-AB99-3E9846EF7589}" type="slidenum">
               <a:rPr lang="en-US" smtClean="0"/>
               <a:t>‹#›</a:t>
             </a:fld>
@@ -2128,7 +2128,7 @@
     </p:spTree>
     <p:extLst>
       <p:ext uri="{BB962C8B-B14F-4D97-AF65-F5344CB8AC3E}">
-        <p14:creationId xmlns:p14="http://schemas.microsoft.com/office/powerpoint/2010/main" val="291192816"/>
+        <p14:creationId xmlns:p14="http://schemas.microsoft.com/office/powerpoint/2010/main" val="2746573160"/>
       </p:ext>
     </p:extLst>
   </p:cSld>
@@ -2160,7 +2160,7 @@
           <p:cNvPr id="2" name="Title 1">
             <a:extLst>
               <a:ext uri="{FF2B5EF4-FFF2-40B4-BE49-F238E27FC236}">
-                <a16:creationId xmlns:a16="http://schemas.microsoft.com/office/drawing/2014/main" id="{E20756C3-3301-4004-9A13-7BC00E7169D6}"/>
+                <a16:creationId xmlns:a16="http://schemas.microsoft.com/office/drawing/2014/main" id="{26F43016-CCD6-44CB-B106-BF98C51AFF22}"/>
               </a:ext>
             </a:extLst>
           </p:cNvPr>
@@ -2197,7 +2197,7 @@
           <p:cNvPr id="3" name="Content Placeholder 2">
             <a:extLst>
               <a:ext uri="{FF2B5EF4-FFF2-40B4-BE49-F238E27FC236}">
-                <a16:creationId xmlns:a16="http://schemas.microsoft.com/office/drawing/2014/main" id="{100C02F3-2962-4355-A9D2-219958AA0814}"/>
+                <a16:creationId xmlns:a16="http://schemas.microsoft.com/office/drawing/2014/main" id="{B2360AC8-EA47-4600-AD13-AB5525AA4B2A}"/>
               </a:ext>
             </a:extLst>
           </p:cNvPr>
@@ -2287,7 +2287,7 @@
           <p:cNvPr id="4" name="Text Placeholder 3">
             <a:extLst>
               <a:ext uri="{FF2B5EF4-FFF2-40B4-BE49-F238E27FC236}">
-                <a16:creationId xmlns:a16="http://schemas.microsoft.com/office/drawing/2014/main" id="{D0ED04FE-C159-4F9B-8532-899CBABFBD6A}"/>
+                <a16:creationId xmlns:a16="http://schemas.microsoft.com/office/drawing/2014/main" id="{3BF17C6D-0F92-4FB5-92E8-C9E5F983A9F5}"/>
               </a:ext>
             </a:extLst>
           </p:cNvPr>
@@ -2358,7 +2358,7 @@
           <p:cNvPr id="5" name="Date Placeholder 4">
             <a:extLst>
               <a:ext uri="{FF2B5EF4-FFF2-40B4-BE49-F238E27FC236}">
-                <a16:creationId xmlns:a16="http://schemas.microsoft.com/office/drawing/2014/main" id="{3F99E429-840B-4B33-8A04-4BA88EC1310D}"/>
+                <a16:creationId xmlns:a16="http://schemas.microsoft.com/office/drawing/2014/main" id="{BED60BC9-861F-42B0-8AD7-9AA03D761361}"/>
               </a:ext>
             </a:extLst>
           </p:cNvPr>
@@ -2374,7 +2374,7 @@
           <a:bodyPr/>
           <a:lstStyle/>
           <a:p>
-            <a:fld id="{73F7D07F-1C37-4603-8754-37B1FBD73B55}" type="datetimeFigureOut">
+            <a:fld id="{5DBD9EBB-3912-4816-B5AB-666E3FD080CD}" type="datetimeFigureOut">
               <a:rPr lang="en-US" smtClean="0"/>
               <a:t>8/14/2026</a:t>
             </a:fld>
@@ -2387,7 +2387,7 @@
           <p:cNvPr id="6" name="Footer Placeholder 5">
             <a:extLst>
               <a:ext uri="{FF2B5EF4-FFF2-40B4-BE49-F238E27FC236}">
-                <a16:creationId xmlns:a16="http://schemas.microsoft.com/office/drawing/2014/main" id="{23F79F86-00E1-40A5-A6AE-85A79440A308}"/>
+                <a16:creationId xmlns:a16="http://schemas.microsoft.com/office/drawing/2014/main" id="{6DA53B8F-DB42-4129-A6A9-554D82C5256F}"/>
               </a:ext>
             </a:extLst>
           </p:cNvPr>
@@ -2412,7 +2412,7 @@
           <p:cNvPr id="7" name="Slide Number Placeholder 6">
             <a:extLst>
               <a:ext uri="{FF2B5EF4-FFF2-40B4-BE49-F238E27FC236}">
-                <a16:creationId xmlns:a16="http://schemas.microsoft.com/office/drawing/2014/main" id="{406B42CC-19E1-4998-AD18-0F2D28479820}"/>
+                <a16:creationId xmlns:a16="http://schemas.microsoft.com/office/drawing/2014/main" id="{B7312CFB-0C71-4244-8691-D716F4DC1B3C}"/>
               </a:ext>
             </a:extLst>
           </p:cNvPr>
@@ -2428,7 +2428,7 @@
           <a:bodyPr/>
           <a:lstStyle/>
           <a:p>
-            <a:fld id="{6DB29B5D-8960-46B2-B219-E18C7AD8C203}" type="slidenum">
+            <a:fld id="{4540F10B-E941-4DDC-AB99-3E9846EF7589}" type="slidenum">
               <a:rPr lang="en-US" smtClean="0"/>
               <a:t>‹#›</a:t>
             </a:fld>
@@ -2439,7 +2439,7 @@
     </p:spTree>
     <p:extLst>
       <p:ext uri="{BB962C8B-B14F-4D97-AF65-F5344CB8AC3E}">
-        <p14:creationId xmlns:p14="http://schemas.microsoft.com/office/powerpoint/2010/main" val="1955616326"/>
+        <p14:creationId xmlns:p14="http://schemas.microsoft.com/office/powerpoint/2010/main" val="2756539680"/>
       </p:ext>
     </p:extLst>
   </p:cSld>
@@ -2471,7 +2471,7 @@
           <p:cNvPr id="2" name="Title 1">
             <a:extLst>
               <a:ext uri="{FF2B5EF4-FFF2-40B4-BE49-F238E27FC236}">
-                <a16:creationId xmlns:a16="http://schemas.microsoft.com/office/drawing/2014/main" id="{ECA2413D-5920-43C6-A7FB-329EB082E960}"/>
+                <a16:creationId xmlns:a16="http://schemas.microsoft.com/office/drawing/2014/main" id="{8FAC6142-63AC-46B4-8485-52290A1624CF}"/>
               </a:ext>
             </a:extLst>
           </p:cNvPr>
@@ -2508,7 +2508,7 @@
           <p:cNvPr id="3" name="Picture Placeholder 2">
             <a:extLst>
               <a:ext uri="{FF2B5EF4-FFF2-40B4-BE49-F238E27FC236}">
-                <a16:creationId xmlns:a16="http://schemas.microsoft.com/office/drawing/2014/main" id="{8717BB00-1CBF-405F-A847-0B7F0066EE2B}"/>
+                <a16:creationId xmlns:a16="http://schemas.microsoft.com/office/drawing/2014/main" id="{C671DEC7-7F55-4A73-8B4A-A253CC8E4E23}"/>
               </a:ext>
             </a:extLst>
           </p:cNvPr>
@@ -2575,7 +2575,7 @@
           <p:cNvPr id="4" name="Text Placeholder 3">
             <a:extLst>
               <a:ext uri="{FF2B5EF4-FFF2-40B4-BE49-F238E27FC236}">
-                <a16:creationId xmlns:a16="http://schemas.microsoft.com/office/drawing/2014/main" id="{F990CA23-2A3D-412F-972F-A6F37FDC9A7B}"/>
+                <a16:creationId xmlns:a16="http://schemas.microsoft.com/office/drawing/2014/main" id="{F859F642-F882-4868-8AD6-AE14E8F7DBD6}"/>
               </a:ext>
             </a:extLst>
           </p:cNvPr>
@@ -2646,7 +2646,7 @@
           <p:cNvPr id="5" name="Date Placeholder 4">
             <a:extLst>
               <a:ext uri="{FF2B5EF4-FFF2-40B4-BE49-F238E27FC236}">
-                <a16:creationId xmlns:a16="http://schemas.microsoft.com/office/drawing/2014/main" id="{4230FDA8-DCED-4B55-A3DD-31D70A5C5B6A}"/>
+                <a16:creationId xmlns:a16="http://schemas.microsoft.com/office/drawing/2014/main" id="{09EB3B54-7E54-4356-A0BC-4D018CFEC072}"/>
               </a:ext>
             </a:extLst>
           </p:cNvPr>
@@ -2662,7 +2662,7 @@
           <a:bodyPr/>
           <a:lstStyle/>
           <a:p>
-            <a:fld id="{73F7D07F-1C37-4603-8754-37B1FBD73B55}" type="datetimeFigureOut">
+            <a:fld id="{5DBD9EBB-3912-4816-B5AB-666E3FD080CD}" type="datetimeFigureOut">
               <a:rPr lang="en-US" smtClean="0"/>
               <a:t>8/14/2026</a:t>
             </a:fld>
@@ -2675,7 +2675,7 @@
           <p:cNvPr id="6" name="Footer Placeholder 5">
             <a:extLst>
               <a:ext uri="{FF2B5EF4-FFF2-40B4-BE49-F238E27FC236}">
-                <a16:creationId xmlns:a16="http://schemas.microsoft.com/office/drawing/2014/main" id="{BBE2420C-AF8E-4CEE-990E-AC859242DD25}"/>
+                <a16:creationId xmlns:a16="http://schemas.microsoft.com/office/drawing/2014/main" id="{C7DE84E2-6F29-489F-B8C1-37B3E4112CE0}"/>
               </a:ext>
             </a:extLst>
           </p:cNvPr>
@@ -2700,7 +2700,7 @@
           <p:cNvPr id="7" name="Slide Number Placeholder 6">
             <a:extLst>
               <a:ext uri="{FF2B5EF4-FFF2-40B4-BE49-F238E27FC236}">
-                <a16:creationId xmlns:a16="http://schemas.microsoft.com/office/drawing/2014/main" id="{26BF2AF8-0917-4698-8972-3E1AB2C80CFE}"/>
+                <a16:creationId xmlns:a16="http://schemas.microsoft.com/office/drawing/2014/main" id="{488EB935-4B02-4867-97A5-753D29D077EB}"/>
               </a:ext>
             </a:extLst>
           </p:cNvPr>
@@ -2716,7 +2716,7 @@
           <a:bodyPr/>
           <a:lstStyle/>
           <a:p>
-            <a:fld id="{6DB29B5D-8960-46B2-B219-E18C7AD8C203}" type="slidenum">
+            <a:fld id="{4540F10B-E941-4DDC-AB99-3E9846EF7589}" type="slidenum">
               <a:rPr lang="en-US" smtClean="0"/>
               <a:t>‹#›</a:t>
             </a:fld>
@@ -2727,7 +2727,7 @@
     </p:spTree>
     <p:extLst>
       <p:ext uri="{BB962C8B-B14F-4D97-AF65-F5344CB8AC3E}">
-        <p14:creationId xmlns:p14="http://schemas.microsoft.com/office/powerpoint/2010/main" val="1122369211"/>
+        <p14:creationId xmlns:p14="http://schemas.microsoft.com/office/powerpoint/2010/main" val="4081291293"/>
       </p:ext>
     </p:extLst>
   </p:cSld>
@@ -2764,7 +2764,7 @@
           <p:cNvPr id="2" name="Title Placeholder 1">
             <a:extLst>
               <a:ext uri="{FF2B5EF4-FFF2-40B4-BE49-F238E27FC236}">
-                <a16:creationId xmlns:a16="http://schemas.microsoft.com/office/drawing/2014/main" id="{FFEB1F29-0319-4C02-B047-1F603E062D03}"/>
+                <a16:creationId xmlns:a16="http://schemas.microsoft.com/office/drawing/2014/main" id="{79A20237-7E88-4929-A585-0857146DF65B}"/>
               </a:ext>
             </a:extLst>
           </p:cNvPr>
@@ -2802,7 +2802,7 @@
           <p:cNvPr id="3" name="Text Placeholder 2">
             <a:extLst>
               <a:ext uri="{FF2B5EF4-FFF2-40B4-BE49-F238E27FC236}">
-                <a16:creationId xmlns:a16="http://schemas.microsoft.com/office/drawing/2014/main" id="{044DF87B-D6FA-4FEC-BE4B-00352932E3B7}"/>
+                <a16:creationId xmlns:a16="http://schemas.microsoft.com/office/drawing/2014/main" id="{99F20AA3-51C0-4630-B5DD-36C460E3AC6A}"/>
               </a:ext>
             </a:extLst>
           </p:cNvPr>
@@ -2869,7 +2869,7 @@
           <p:cNvPr id="4" name="Date Placeholder 3">
             <a:extLst>
               <a:ext uri="{FF2B5EF4-FFF2-40B4-BE49-F238E27FC236}">
-                <a16:creationId xmlns:a16="http://schemas.microsoft.com/office/drawing/2014/main" id="{4DEC66FD-CFAB-4E03-805F-5998491818A7}"/>
+                <a16:creationId xmlns:a16="http://schemas.microsoft.com/office/drawing/2014/main" id="{D38D56FA-85F6-4CD7-BE7E-0C2A53392D5A}"/>
               </a:ext>
             </a:extLst>
           </p:cNvPr>
@@ -2903,7 +2903,7 @@
             </a:lvl1pPr>
           </a:lstStyle>
           <a:p>
-            <a:fld id="{73F7D07F-1C37-4603-8754-37B1FBD73B55}" type="datetimeFigureOut">
+            <a:fld id="{5DBD9EBB-3912-4816-B5AB-666E3FD080CD}" type="datetimeFigureOut">
               <a:rPr lang="en-US" smtClean="0"/>
               <a:t>8/14/2026</a:t>
             </a:fld>
@@ -2916,7 +2916,7 @@
           <p:cNvPr id="5" name="Footer Placeholder 4">
             <a:extLst>
               <a:ext uri="{FF2B5EF4-FFF2-40B4-BE49-F238E27FC236}">
-                <a16:creationId xmlns:a16="http://schemas.microsoft.com/office/drawing/2014/main" id="{E2C7FBEB-BF2A-4DD6-BEE4-7243434B10C3}"/>
+                <a16:creationId xmlns:a16="http://schemas.microsoft.com/office/drawing/2014/main" id="{2D706F5C-6886-4942-9519-C2E086BFEB86}"/>
               </a:ext>
             </a:extLst>
           </p:cNvPr>
@@ -2959,7 +2959,7 @@
           <p:cNvPr id="6" name="Slide Number Placeholder 5">
             <a:extLst>
               <a:ext uri="{FF2B5EF4-FFF2-40B4-BE49-F238E27FC236}">
-                <a16:creationId xmlns:a16="http://schemas.microsoft.com/office/drawing/2014/main" id="{740D9390-8AB1-480C-9758-0834DF42E51C}"/>
+                <a16:creationId xmlns:a16="http://schemas.microsoft.com/office/drawing/2014/main" id="{2698D9B7-CF86-4561-B6E1-6213E667A386}"/>
               </a:ext>
             </a:extLst>
           </p:cNvPr>
@@ -2993,7 +2993,7 @@
             </a:lvl1pPr>
           </a:lstStyle>
           <a:p>
-            <a:fld id="{6DB29B5D-8960-46B2-B219-E18C7AD8C203}" type="slidenum">
+            <a:fld id="{4540F10B-E941-4DDC-AB99-3E9846EF7589}" type="slidenum">
               <a:rPr lang="en-US" smtClean="0"/>
               <a:t>‹#›</a:t>
             </a:fld>
@@ -3004,7 +3004,7 @@
     </p:spTree>
     <p:extLst>
       <p:ext uri="{BB962C8B-B14F-4D97-AF65-F5344CB8AC3E}">
-        <p14:creationId xmlns:p14="http://schemas.microsoft.com/office/powerpoint/2010/main" val="277145790"/>
+        <p14:creationId xmlns:p14="http://schemas.microsoft.com/office/powerpoint/2010/main" val="1845585144"/>
       </p:ext>
     </p:extLst>
   </p:cSld>
@@ -3327,7 +3327,7 @@
           <p:cNvPr id="2" name="Rectangle 1">
             <a:extLst>
               <a:ext uri="{FF2B5EF4-FFF2-40B4-BE49-F238E27FC236}">
-                <a16:creationId xmlns:a16="http://schemas.microsoft.com/office/drawing/2014/main" id="{A2D4727B-403A-4F9C-BE8B-CE7BEC987653}"/>
+                <a16:creationId xmlns:a16="http://schemas.microsoft.com/office/drawing/2014/main" id="{54BA1AA1-1CBE-4FB1-90F9-C75BA1033712}"/>
               </a:ext>
             </a:extLst>
           </p:cNvPr>
@@ -3395,7 +3395,7 @@
           <p:cNvPr id="3" name="Rectangle 2">
             <a:extLst>
               <a:ext uri="{FF2B5EF4-FFF2-40B4-BE49-F238E27FC236}">
-                <a16:creationId xmlns:a16="http://schemas.microsoft.com/office/drawing/2014/main" id="{BF599ED0-9A04-46F2-A0AB-44A1A6037799}"/>
+                <a16:creationId xmlns:a16="http://schemas.microsoft.com/office/drawing/2014/main" id="{6F368843-26FB-4B70-AE4C-8954FC0D193F}"/>
               </a:ext>
             </a:extLst>
           </p:cNvPr>
@@ -3464,7 +3464,7 @@
             <a:hlinkClick r:id="rId2"/>
             <a:extLst>
               <a:ext uri="{FF2B5EF4-FFF2-40B4-BE49-F238E27FC236}">
-                <a16:creationId xmlns:a16="http://schemas.microsoft.com/office/drawing/2014/main" id="{9C0DEAC9-9CD7-45DB-B2A1-24A2456F1ABC}"/>
+                <a16:creationId xmlns:a16="http://schemas.microsoft.com/office/drawing/2014/main" id="{9E010BD2-0EE1-4EA5-AF96-1B3AD68B78C7}"/>
               </a:ext>
             </a:extLst>
           </p:cNvPr>
@@ -3540,7 +3540,7 @@
           <p:cNvPr id="5" name="Rectangle 4">
             <a:extLst>
               <a:ext uri="{FF2B5EF4-FFF2-40B4-BE49-F238E27FC236}">
-                <a16:creationId xmlns:a16="http://schemas.microsoft.com/office/drawing/2014/main" id="{7B03C757-91F6-4843-92D7-F26B65AF47C2}"/>
+                <a16:creationId xmlns:a16="http://schemas.microsoft.com/office/drawing/2014/main" id="{2B301AD7-FD36-4342-924A-6100D0E65211}"/>
               </a:ext>
             </a:extLst>
           </p:cNvPr>
@@ -3594,7 +3594,7 @@
           <p:cNvPr id="6" name="TextBox 5">
             <a:extLst>
               <a:ext uri="{FF2B5EF4-FFF2-40B4-BE49-F238E27FC236}">
-                <a16:creationId xmlns:a16="http://schemas.microsoft.com/office/drawing/2014/main" id="{3D469180-907C-4708-A29F-4ECA260D74BF}"/>
+                <a16:creationId xmlns:a16="http://schemas.microsoft.com/office/drawing/2014/main" id="{3616ED7B-B709-4EC1-8458-F01FA131F5DD}"/>
               </a:ext>
             </a:extLst>
           </p:cNvPr>
@@ -3634,7 +3634,7 @@
           <p:cNvPr id="7" name="TextBox 6">
             <a:extLst>
               <a:ext uri="{FF2B5EF4-FFF2-40B4-BE49-F238E27FC236}">
-                <a16:creationId xmlns:a16="http://schemas.microsoft.com/office/drawing/2014/main" id="{DB5A1EBB-26E3-4D5B-B88C-82B38F036AD2}"/>
+                <a16:creationId xmlns:a16="http://schemas.microsoft.com/office/drawing/2014/main" id="{F4F28C20-97D4-4A37-81AE-336A73C589DE}"/>
               </a:ext>
             </a:extLst>
           </p:cNvPr>
@@ -3681,7 +3681,7 @@
             <a:hlinkClick r:id="rId2"/>
             <a:extLst>
               <a:ext uri="{FF2B5EF4-FFF2-40B4-BE49-F238E27FC236}">
-                <a16:creationId xmlns:a16="http://schemas.microsoft.com/office/drawing/2014/main" id="{19201E95-89A9-43EC-A5A3-B2393C67CD5E}"/>
+                <a16:creationId xmlns:a16="http://schemas.microsoft.com/office/drawing/2014/main" id="{2D91CF40-B620-4942-A5B4-867B57CBDC8F}"/>
               </a:ext>
             </a:extLst>
           </p:cNvPr>
@@ -3736,7 +3736,7 @@
             <a:hlinkClick r:id="rId2"/>
             <a:extLst>
               <a:ext uri="{FF2B5EF4-FFF2-40B4-BE49-F238E27FC236}">
-                <a16:creationId xmlns:a16="http://schemas.microsoft.com/office/drawing/2014/main" id="{99099D70-7542-4B33-AEA6-18EC0AC1E89A}"/>
+                <a16:creationId xmlns:a16="http://schemas.microsoft.com/office/drawing/2014/main" id="{BE29F051-3C0D-4DC8-A581-7E789000F835}"/>
               </a:ext>
             </a:extLst>
           </p:cNvPr>
@@ -3773,7 +3773,7 @@
             <a:hlinkClick r:id="rId2"/>
             <a:extLst>
               <a:ext uri="{FF2B5EF4-FFF2-40B4-BE49-F238E27FC236}">
-                <a16:creationId xmlns:a16="http://schemas.microsoft.com/office/drawing/2014/main" id="{0715C531-A512-4F90-867C-B3FCE8F36EC8}"/>
+                <a16:creationId xmlns:a16="http://schemas.microsoft.com/office/drawing/2014/main" id="{5C6D41F9-311F-4EAE-A061-877E7ED858DF}"/>
               </a:ext>
             </a:extLst>
           </p:cNvPr>
@@ -3855,7 +3855,7 @@
           <p:cNvPr id="12" name="TextBox 11">
             <a:extLst>
               <a:ext uri="{FF2B5EF4-FFF2-40B4-BE49-F238E27FC236}">
-                <a16:creationId xmlns:a16="http://schemas.microsoft.com/office/drawing/2014/main" id="{D60DB431-F66B-4885-8AF8-886E5643A0D4}"/>
+                <a16:creationId xmlns:a16="http://schemas.microsoft.com/office/drawing/2014/main" id="{1E557851-6609-4B71-A4C9-AD0FC02C73C0}"/>
               </a:ext>
             </a:extLst>
           </p:cNvPr>
@@ -3901,7 +3901,7 @@
           <p:cNvPr id="13" name="TextBox 12">
             <a:extLst>
               <a:ext uri="{FF2B5EF4-FFF2-40B4-BE49-F238E27FC236}">
-                <a16:creationId xmlns:a16="http://schemas.microsoft.com/office/drawing/2014/main" id="{53FB73F0-5998-4E85-B0E7-95D90485A89A}"/>
+                <a16:creationId xmlns:a16="http://schemas.microsoft.com/office/drawing/2014/main" id="{626368AC-5CCF-4FBB-9CC2-40DB9392AE4F}"/>
               </a:ext>
             </a:extLst>
           </p:cNvPr>
@@ -3949,7 +3949,7 @@
             <a:hlinkClick r:id="rId2"/>
             <a:extLst>
               <a:ext uri="{FF2B5EF4-FFF2-40B4-BE49-F238E27FC236}">
-                <a16:creationId xmlns:a16="http://schemas.microsoft.com/office/drawing/2014/main" id="{55149E50-1A5F-4234-BB67-6493389A3BA8}"/>
+                <a16:creationId xmlns:a16="http://schemas.microsoft.com/office/drawing/2014/main" id="{BB6B785B-5D58-4337-B2EB-B351C3BE1252}"/>
               </a:ext>
             </a:extLst>
           </p:cNvPr>
@@ -4026,7 +4026,7 @@
             <a:hlinkClick r:id="rId2"/>
             <a:extLst>
               <a:ext uri="{FF2B5EF4-FFF2-40B4-BE49-F238E27FC236}">
-                <a16:creationId xmlns:a16="http://schemas.microsoft.com/office/drawing/2014/main" id="{EF29850A-2D86-4DA0-93E5-451247D569D1}"/>
+                <a16:creationId xmlns:a16="http://schemas.microsoft.com/office/drawing/2014/main" id="{AE085656-21D8-401A-9437-12AFD861EE58}"/>
               </a:ext>
             </a:extLst>
           </p:cNvPr>
@@ -4081,7 +4081,7 @@
             <a:hlinkClick r:id="rId2"/>
             <a:extLst>
               <a:ext uri="{FF2B5EF4-FFF2-40B4-BE49-F238E27FC236}">
-                <a16:creationId xmlns:a16="http://schemas.microsoft.com/office/drawing/2014/main" id="{91543019-E27C-4F6F-A851-60BF15A40D72}"/>
+                <a16:creationId xmlns:a16="http://schemas.microsoft.com/office/drawing/2014/main" id="{0C99CB37-0842-4565-A6F2-7410ABC6D06A}"/>
               </a:ext>
             </a:extLst>
           </p:cNvPr>
@@ -4118,7 +4118,7 @@
             <a:hlinkClick r:id="rId2"/>
             <a:extLst>
               <a:ext uri="{FF2B5EF4-FFF2-40B4-BE49-F238E27FC236}">
-                <a16:creationId xmlns:a16="http://schemas.microsoft.com/office/drawing/2014/main" id="{FE75A572-5BBB-48A0-8AEE-5C0804F7C79D}"/>
+                <a16:creationId xmlns:a16="http://schemas.microsoft.com/office/drawing/2014/main" id="{47E9122E-F5AD-4EF5-A5EA-1EA3D0FF523D}"/>
               </a:ext>
             </a:extLst>
           </p:cNvPr>
@@ -4194,7 +4194,7 @@
           <p:cNvPr id="19" name="TextBox 18">
             <a:extLst>
               <a:ext uri="{FF2B5EF4-FFF2-40B4-BE49-F238E27FC236}">
-                <a16:creationId xmlns:a16="http://schemas.microsoft.com/office/drawing/2014/main" id="{52149688-8692-4B23-B6B1-FF1F57DC723B}"/>
+                <a16:creationId xmlns:a16="http://schemas.microsoft.com/office/drawing/2014/main" id="{0AA617C3-0D24-4D5E-86B2-70B1F0E63CCC}"/>
               </a:ext>
             </a:extLst>
           </p:cNvPr>
@@ -4234,7 +4234,7 @@
           <p:cNvPr id="20" name="TextBox 19">
             <a:extLst>
               <a:ext uri="{FF2B5EF4-FFF2-40B4-BE49-F238E27FC236}">
-                <a16:creationId xmlns:a16="http://schemas.microsoft.com/office/drawing/2014/main" id="{04444BA0-5AB0-4C01-8166-9E1FDAF6E792}"/>
+                <a16:creationId xmlns:a16="http://schemas.microsoft.com/office/drawing/2014/main" id="{76964A3D-39BC-4D9D-AD50-6FED40644776}"/>
               </a:ext>
             </a:extLst>
           </p:cNvPr>
@@ -4282,7 +4282,7 @@
             <a:hlinkClick r:id="rId2"/>
             <a:extLst>
               <a:ext uri="{FF2B5EF4-FFF2-40B4-BE49-F238E27FC236}">
-                <a16:creationId xmlns:a16="http://schemas.microsoft.com/office/drawing/2014/main" id="{E6285855-6646-45BE-8A2F-8BC2B5A13461}"/>
+                <a16:creationId xmlns:a16="http://schemas.microsoft.com/office/drawing/2014/main" id="{423936D5-C000-4A90-BD3A-BC81AC05FE9C}"/>
               </a:ext>
             </a:extLst>
           </p:cNvPr>
@@ -4359,7 +4359,7 @@
             <a:hlinkClick r:id="rId2"/>
             <a:extLst>
               <a:ext uri="{FF2B5EF4-FFF2-40B4-BE49-F238E27FC236}">
-                <a16:creationId xmlns:a16="http://schemas.microsoft.com/office/drawing/2014/main" id="{71C1F82C-F284-4AF6-9FD5-26B40794D2A4}"/>
+                <a16:creationId xmlns:a16="http://schemas.microsoft.com/office/drawing/2014/main" id="{2521B033-5686-42F5-BAE0-AC85DAB5BC3B}"/>
               </a:ext>
             </a:extLst>
           </p:cNvPr>
@@ -4414,7 +4414,7 @@
             <a:hlinkClick r:id="rId2"/>
             <a:extLst>
               <a:ext uri="{FF2B5EF4-FFF2-40B4-BE49-F238E27FC236}">
-                <a16:creationId xmlns:a16="http://schemas.microsoft.com/office/drawing/2014/main" id="{3EE491AC-9FA4-40D1-95F6-FE70BAB0D9BA}"/>
+                <a16:creationId xmlns:a16="http://schemas.microsoft.com/office/drawing/2014/main" id="{5A2B4F8A-119F-49B4-8F34-5FD82FC72455}"/>
               </a:ext>
             </a:extLst>
           </p:cNvPr>
@@ -4451,7 +4451,7 @@
             <a:hlinkClick r:id="rId2"/>
             <a:extLst>
               <a:ext uri="{FF2B5EF4-FFF2-40B4-BE49-F238E27FC236}">
-                <a16:creationId xmlns:a16="http://schemas.microsoft.com/office/drawing/2014/main" id="{7EADCE1F-80EC-45C4-A94A-54574A2F8806}"/>
+                <a16:creationId xmlns:a16="http://schemas.microsoft.com/office/drawing/2014/main" id="{7892CF28-0122-4D4D-98AC-F19D33725C29}"/>
               </a:ext>
             </a:extLst>
           </p:cNvPr>
@@ -4527,7 +4527,7 @@
           <p:cNvPr id="26" name="TextBox 25">
             <a:extLst>
               <a:ext uri="{FF2B5EF4-FFF2-40B4-BE49-F238E27FC236}">
-                <a16:creationId xmlns:a16="http://schemas.microsoft.com/office/drawing/2014/main" id="{B486A838-0599-4983-A880-82BB51F93A8F}"/>
+                <a16:creationId xmlns:a16="http://schemas.microsoft.com/office/drawing/2014/main" id="{F526B200-C0A0-46F8-91D0-9F788F893213}"/>
               </a:ext>
             </a:extLst>
           </p:cNvPr>
@@ -4567,7 +4567,7 @@
           <p:cNvPr id="27" name="TextBox 26">
             <a:extLst>
               <a:ext uri="{FF2B5EF4-FFF2-40B4-BE49-F238E27FC236}">
-                <a16:creationId xmlns:a16="http://schemas.microsoft.com/office/drawing/2014/main" id="{BC530017-38C0-4048-A23C-3C13EBC60BE9}"/>
+                <a16:creationId xmlns:a16="http://schemas.microsoft.com/office/drawing/2014/main" id="{10DB49DD-CE08-4F76-B71D-8CC2FA8B8489}"/>
               </a:ext>
             </a:extLst>
           </p:cNvPr>
@@ -4615,7 +4615,7 @@
             <a:hlinkClick r:id="rId2"/>
             <a:extLst>
               <a:ext uri="{FF2B5EF4-FFF2-40B4-BE49-F238E27FC236}">
-                <a16:creationId xmlns:a16="http://schemas.microsoft.com/office/drawing/2014/main" id="{C382E101-66F1-4FE3-9A0E-6D00A55EB8D9}"/>
+                <a16:creationId xmlns:a16="http://schemas.microsoft.com/office/drawing/2014/main" id="{9B5CF1D3-7958-423E-9774-708EA8FFD93C}"/>
               </a:ext>
             </a:extLst>
           </p:cNvPr>
@@ -4692,7 +4692,7 @@
             <a:hlinkClick r:id="rId2"/>
             <a:extLst>
               <a:ext uri="{FF2B5EF4-FFF2-40B4-BE49-F238E27FC236}">
-                <a16:creationId xmlns:a16="http://schemas.microsoft.com/office/drawing/2014/main" id="{DC072043-B136-458B-AF56-DFBB8186C23D}"/>
+                <a16:creationId xmlns:a16="http://schemas.microsoft.com/office/drawing/2014/main" id="{19C244AE-DEF6-4469-939C-E80EB6E1E0A0}"/>
               </a:ext>
             </a:extLst>
           </p:cNvPr>
@@ -4747,7 +4747,7 @@
             <a:hlinkClick r:id="rId2"/>
             <a:extLst>
               <a:ext uri="{FF2B5EF4-FFF2-40B4-BE49-F238E27FC236}">
-                <a16:creationId xmlns:a16="http://schemas.microsoft.com/office/drawing/2014/main" id="{858E061B-9CFF-40D5-BEEF-EB7DC8AF8177}"/>
+                <a16:creationId xmlns:a16="http://schemas.microsoft.com/office/drawing/2014/main" id="{7C4833A4-50BF-4F06-8151-0B280E59D0A4}"/>
               </a:ext>
             </a:extLst>
           </p:cNvPr>
@@ -4784,7 +4784,7 @@
             <a:hlinkClick r:id="rId2"/>
             <a:extLst>
               <a:ext uri="{FF2B5EF4-FFF2-40B4-BE49-F238E27FC236}">
-                <a16:creationId xmlns:a16="http://schemas.microsoft.com/office/drawing/2014/main" id="{BF1C03B2-1E6F-43F2-BC91-80BFF7FD6400}"/>
+                <a16:creationId xmlns:a16="http://schemas.microsoft.com/office/drawing/2014/main" id="{7911659D-F63D-4055-A99E-1434B38B943B}"/>
               </a:ext>
             </a:extLst>
           </p:cNvPr>
@@ -4860,7 +4860,7 @@
           <p:cNvPr id="33" name="TextBox 32">
             <a:extLst>
               <a:ext uri="{FF2B5EF4-FFF2-40B4-BE49-F238E27FC236}">
-                <a16:creationId xmlns:a16="http://schemas.microsoft.com/office/drawing/2014/main" id="{8E837DBC-36EF-420A-86F0-8FBA11746B75}"/>
+                <a16:creationId xmlns:a16="http://schemas.microsoft.com/office/drawing/2014/main" id="{222D0896-9043-42ED-883F-C2B1B35471B3}"/>
               </a:ext>
             </a:extLst>
           </p:cNvPr>
@@ -4900,7 +4900,7 @@
           <p:cNvPr id="34" name="TextBox 33">
             <a:extLst>
               <a:ext uri="{FF2B5EF4-FFF2-40B4-BE49-F238E27FC236}">
-                <a16:creationId xmlns:a16="http://schemas.microsoft.com/office/drawing/2014/main" id="{E1D6AE27-A8F4-4D0A-9166-0CE2A02A926F}"/>
+                <a16:creationId xmlns:a16="http://schemas.microsoft.com/office/drawing/2014/main" id="{5FCF5A01-1316-4A21-B7E2-41514D84091C}"/>
               </a:ext>
             </a:extLst>
           </p:cNvPr>
@@ -4942,7 +4942,7 @@
             <a:hlinkClick r:id="rId2"/>
             <a:extLst>
               <a:ext uri="{FF2B5EF4-FFF2-40B4-BE49-F238E27FC236}">
-                <a16:creationId xmlns:a16="http://schemas.microsoft.com/office/drawing/2014/main" id="{922B89D5-FE0E-46E6-861F-EB49F429A7E1}"/>
+                <a16:creationId xmlns:a16="http://schemas.microsoft.com/office/drawing/2014/main" id="{E28613F6-FB3E-4CF4-B3AA-9FB86ED7632B}"/>
               </a:ext>
             </a:extLst>
           </p:cNvPr>
@@ -5018,7 +5018,7 @@
           <p:cNvPr id="36" name="Rectangle 35">
             <a:extLst>
               <a:ext uri="{FF2B5EF4-FFF2-40B4-BE49-F238E27FC236}">
-                <a16:creationId xmlns:a16="http://schemas.microsoft.com/office/drawing/2014/main" id="{BAD74803-D547-401A-BBB9-0F209B673491}"/>
+                <a16:creationId xmlns:a16="http://schemas.microsoft.com/office/drawing/2014/main" id="{371D6F56-CC5A-46BC-969C-1424B2A714ED}"/>
               </a:ext>
             </a:extLst>
           </p:cNvPr>
@@ -5072,7 +5072,7 @@
           <p:cNvPr id="37" name="TextBox 36">
             <a:extLst>
               <a:ext uri="{FF2B5EF4-FFF2-40B4-BE49-F238E27FC236}">
-                <a16:creationId xmlns:a16="http://schemas.microsoft.com/office/drawing/2014/main" id="{440B3369-F6E0-48EA-AF4D-7362F42B8D4E}"/>
+                <a16:creationId xmlns:a16="http://schemas.microsoft.com/office/drawing/2014/main" id="{73B9E851-3B27-496C-BF08-C5F4603DA792}"/>
               </a:ext>
             </a:extLst>
           </p:cNvPr>
@@ -5114,7 +5114,7 @@
             <a:hlinkClick r:id="rId2"/>
             <a:extLst>
               <a:ext uri="{FF2B5EF4-FFF2-40B4-BE49-F238E27FC236}">
-                <a16:creationId xmlns:a16="http://schemas.microsoft.com/office/drawing/2014/main" id="{6B9973CB-77E2-4BDE-A1CC-BC2051C0A9C6}"/>
+                <a16:creationId xmlns:a16="http://schemas.microsoft.com/office/drawing/2014/main" id="{04205895-2812-4142-AFC4-0DF0AAFE647C}"/>
               </a:ext>
             </a:extLst>
           </p:cNvPr>
@@ -5188,7 +5188,7 @@
     </p:spTree>
     <p:extLst>
       <p:ext uri="{BB962C8B-B14F-4D97-AF65-F5344CB8AC3E}">
-        <p14:creationId xmlns:p14="http://schemas.microsoft.com/office/powerpoint/2010/main" val="15430664"/>
+        <p14:creationId xmlns:p14="http://schemas.microsoft.com/office/powerpoint/2010/main" val="1652940719"/>
       </p:ext>
     </p:extLst>
   </p:cSld>
@@ -5220,7 +5220,7 @@
           <p:cNvPr id="2" name="Rectangle 1">
             <a:extLst>
               <a:ext uri="{FF2B5EF4-FFF2-40B4-BE49-F238E27FC236}">
-                <a16:creationId xmlns:a16="http://schemas.microsoft.com/office/drawing/2014/main" id="{C43356E9-BA68-4598-AFFB-340C5C9156BA}"/>
+                <a16:creationId xmlns:a16="http://schemas.microsoft.com/office/drawing/2014/main" id="{3CD51B86-AA3E-428E-9D2E-C08452473661}"/>
               </a:ext>
             </a:extLst>
           </p:cNvPr>
@@ -5288,7 +5288,7 @@
           <p:cNvPr id="3" name="Rectangle 2">
             <a:extLst>
               <a:ext uri="{FF2B5EF4-FFF2-40B4-BE49-F238E27FC236}">
-                <a16:creationId xmlns:a16="http://schemas.microsoft.com/office/drawing/2014/main" id="{32156F35-0645-4BE2-962D-144102BEF6B2}"/>
+                <a16:creationId xmlns:a16="http://schemas.microsoft.com/office/drawing/2014/main" id="{F6AB935B-3FBC-4B12-8E91-930CD1B0A71C}"/>
               </a:ext>
             </a:extLst>
           </p:cNvPr>
@@ -5357,7 +5357,7 @@
             <a:hlinkClick r:id="rId2"/>
             <a:extLst>
               <a:ext uri="{FF2B5EF4-FFF2-40B4-BE49-F238E27FC236}">
-                <a16:creationId xmlns:a16="http://schemas.microsoft.com/office/drawing/2014/main" id="{7F050082-5077-49F0-9A30-3692E7CBC048}"/>
+                <a16:creationId xmlns:a16="http://schemas.microsoft.com/office/drawing/2014/main" id="{10A0E53A-94F4-4968-9BEE-595397303474}"/>
               </a:ext>
             </a:extLst>
           </p:cNvPr>
@@ -5433,7 +5433,7 @@
           <p:cNvPr id="5" name="Rectangle 4">
             <a:extLst>
               <a:ext uri="{FF2B5EF4-FFF2-40B4-BE49-F238E27FC236}">
-                <a16:creationId xmlns:a16="http://schemas.microsoft.com/office/drawing/2014/main" id="{F001E890-3D7B-422D-87C8-42563C218383}"/>
+                <a16:creationId xmlns:a16="http://schemas.microsoft.com/office/drawing/2014/main" id="{4EC35BB6-A72B-419F-8C05-BCB98B550D6D}"/>
               </a:ext>
             </a:extLst>
           </p:cNvPr>
@@ -5487,7 +5487,7 @@
           <p:cNvPr id="6" name="TextBox 5">
             <a:extLst>
               <a:ext uri="{FF2B5EF4-FFF2-40B4-BE49-F238E27FC236}">
-                <a16:creationId xmlns:a16="http://schemas.microsoft.com/office/drawing/2014/main" id="{CC7D5576-27B1-41C7-9D57-033D1D11C203}"/>
+                <a16:creationId xmlns:a16="http://schemas.microsoft.com/office/drawing/2014/main" id="{176DFD36-A5BB-49A8-B2C2-D0E4CB30055F}"/>
               </a:ext>
             </a:extLst>
           </p:cNvPr>
@@ -5527,7 +5527,7 @@
           <p:cNvPr id="7" name="TextBox 6">
             <a:extLst>
               <a:ext uri="{FF2B5EF4-FFF2-40B4-BE49-F238E27FC236}">
-                <a16:creationId xmlns:a16="http://schemas.microsoft.com/office/drawing/2014/main" id="{F598DCBD-F85B-4A9A-B826-812C2DDB6DD7}"/>
+                <a16:creationId xmlns:a16="http://schemas.microsoft.com/office/drawing/2014/main" id="{98DA4498-2B3F-408C-B94A-3B8542FEED61}"/>
               </a:ext>
             </a:extLst>
           </p:cNvPr>
@@ -5568,7 +5568,7 @@
             <a:hlinkClick r:id="rId2"/>
             <a:extLst>
               <a:ext uri="{FF2B5EF4-FFF2-40B4-BE49-F238E27FC236}">
-                <a16:creationId xmlns:a16="http://schemas.microsoft.com/office/drawing/2014/main" id="{84C58E01-FE2B-4DF0-AD5E-D93B623E2FED}"/>
+                <a16:creationId xmlns:a16="http://schemas.microsoft.com/office/drawing/2014/main" id="{9144B756-9FEE-4583-9096-EB47E6B0E074}"/>
               </a:ext>
             </a:extLst>
           </p:cNvPr>
@@ -5623,7 +5623,7 @@
             <a:hlinkClick r:id="rId2"/>
             <a:extLst>
               <a:ext uri="{FF2B5EF4-FFF2-40B4-BE49-F238E27FC236}">
-                <a16:creationId xmlns:a16="http://schemas.microsoft.com/office/drawing/2014/main" id="{6A29E58C-B52F-47F2-97F2-AADAAC87A70B}"/>
+                <a16:creationId xmlns:a16="http://schemas.microsoft.com/office/drawing/2014/main" id="{8D8E3B7E-FBE9-4A23-8356-232A0174FC01}"/>
               </a:ext>
             </a:extLst>
           </p:cNvPr>
@@ -5660,7 +5660,7 @@
             <a:hlinkClick r:id="rId2"/>
             <a:extLst>
               <a:ext uri="{FF2B5EF4-FFF2-40B4-BE49-F238E27FC236}">
-                <a16:creationId xmlns:a16="http://schemas.microsoft.com/office/drawing/2014/main" id="{BF3D9BC6-DE50-4270-8BB2-26F1644BFDB8}"/>
+                <a16:creationId xmlns:a16="http://schemas.microsoft.com/office/drawing/2014/main" id="{7A884BF0-EE2C-4EAE-9F03-9FD4892FBDD1}"/>
               </a:ext>
             </a:extLst>
           </p:cNvPr>
@@ -5736,7 +5736,7 @@
           <p:cNvPr id="12" name="TextBox 11">
             <a:extLst>
               <a:ext uri="{FF2B5EF4-FFF2-40B4-BE49-F238E27FC236}">
-                <a16:creationId xmlns:a16="http://schemas.microsoft.com/office/drawing/2014/main" id="{650FD00D-3A1D-4DB8-9339-20C7736C996C}"/>
+                <a16:creationId xmlns:a16="http://schemas.microsoft.com/office/drawing/2014/main" id="{32CDD5BD-6BBE-432C-A7E6-924852538508}"/>
               </a:ext>
             </a:extLst>
           </p:cNvPr>
@@ -5776,7 +5776,7 @@
           <p:cNvPr id="13" name="TextBox 12">
             <a:extLst>
               <a:ext uri="{FF2B5EF4-FFF2-40B4-BE49-F238E27FC236}">
-                <a16:creationId xmlns:a16="http://schemas.microsoft.com/office/drawing/2014/main" id="{2CA2ACE0-48CB-45C0-934E-1C7037B074AB}"/>
+                <a16:creationId xmlns:a16="http://schemas.microsoft.com/office/drawing/2014/main" id="{901345DF-3352-4F5B-883C-F0E801FE9D25}"/>
               </a:ext>
             </a:extLst>
           </p:cNvPr>
@@ -5818,7 +5818,7 @@
             <a:hlinkClick r:id="rId2"/>
             <a:extLst>
               <a:ext uri="{FF2B5EF4-FFF2-40B4-BE49-F238E27FC236}">
-                <a16:creationId xmlns:a16="http://schemas.microsoft.com/office/drawing/2014/main" id="{335EF037-67B6-4AF5-AED4-41930F2C4941}"/>
+                <a16:creationId xmlns:a16="http://schemas.microsoft.com/office/drawing/2014/main" id="{6C27A57E-991D-4492-82A3-FCF2AC188E7D}"/>
               </a:ext>
             </a:extLst>
           </p:cNvPr>
@@ -5895,7 +5895,7 @@
             <a:hlinkClick r:id="rId2"/>
             <a:extLst>
               <a:ext uri="{FF2B5EF4-FFF2-40B4-BE49-F238E27FC236}">
-                <a16:creationId xmlns:a16="http://schemas.microsoft.com/office/drawing/2014/main" id="{9605BCCD-B008-4EDE-A4AB-AB3DE79B0DE4}"/>
+                <a16:creationId xmlns:a16="http://schemas.microsoft.com/office/drawing/2014/main" id="{31F1CC93-07FA-4F38-8348-E303916C9867}"/>
               </a:ext>
             </a:extLst>
           </p:cNvPr>
@@ -5950,7 +5950,7 @@
             <a:hlinkClick r:id="rId2"/>
             <a:extLst>
               <a:ext uri="{FF2B5EF4-FFF2-40B4-BE49-F238E27FC236}">
-                <a16:creationId xmlns:a16="http://schemas.microsoft.com/office/drawing/2014/main" id="{4B4C5C18-69A0-4B49-BAB9-331411E2E291}"/>
+                <a16:creationId xmlns:a16="http://schemas.microsoft.com/office/drawing/2014/main" id="{BE0DD09B-F764-432D-8D0A-0EE957116999}"/>
               </a:ext>
             </a:extLst>
           </p:cNvPr>
@@ -5987,7 +5987,7 @@
             <a:hlinkClick r:id="rId2"/>
             <a:extLst>
               <a:ext uri="{FF2B5EF4-FFF2-40B4-BE49-F238E27FC236}">
-                <a16:creationId xmlns:a16="http://schemas.microsoft.com/office/drawing/2014/main" id="{2F27575B-6700-4E43-A512-793C5157116F}"/>
+                <a16:creationId xmlns:a16="http://schemas.microsoft.com/office/drawing/2014/main" id="{173F0EAA-DC18-4810-BB36-B69C27BB8620}"/>
               </a:ext>
             </a:extLst>
           </p:cNvPr>
@@ -6063,7 +6063,7 @@
           <p:cNvPr id="19" name="TextBox 18">
             <a:extLst>
               <a:ext uri="{FF2B5EF4-FFF2-40B4-BE49-F238E27FC236}">
-                <a16:creationId xmlns:a16="http://schemas.microsoft.com/office/drawing/2014/main" id="{B11672D2-BC75-45A4-989E-CF7766BA6DF6}"/>
+                <a16:creationId xmlns:a16="http://schemas.microsoft.com/office/drawing/2014/main" id="{5E5A5A24-E0BE-4F63-A9F2-A319DA5DCC5A}"/>
               </a:ext>
             </a:extLst>
           </p:cNvPr>
@@ -6103,7 +6103,7 @@
           <p:cNvPr id="20" name="TextBox 19">
             <a:extLst>
               <a:ext uri="{FF2B5EF4-FFF2-40B4-BE49-F238E27FC236}">
-                <a16:creationId xmlns:a16="http://schemas.microsoft.com/office/drawing/2014/main" id="{8AF8FF32-4055-4C54-A1C7-AF95B79B0DBC}"/>
+                <a16:creationId xmlns:a16="http://schemas.microsoft.com/office/drawing/2014/main" id="{18EEECBB-34D4-42F5-926D-6C9AC31F4A22}"/>
               </a:ext>
             </a:extLst>
           </p:cNvPr>
@@ -6145,7 +6145,7 @@
             <a:hlinkClick r:id="rId2"/>
             <a:extLst>
               <a:ext uri="{FF2B5EF4-FFF2-40B4-BE49-F238E27FC236}">
-                <a16:creationId xmlns:a16="http://schemas.microsoft.com/office/drawing/2014/main" id="{9AC5D22F-A5DA-411A-B2A8-8D7CD4903720}"/>
+                <a16:creationId xmlns:a16="http://schemas.microsoft.com/office/drawing/2014/main" id="{3B7B2D68-F48A-4BBA-A132-5D4F97AC863F}"/>
               </a:ext>
             </a:extLst>
           </p:cNvPr>
@@ -6222,7 +6222,7 @@
             <a:hlinkClick r:id="rId2"/>
             <a:extLst>
               <a:ext uri="{FF2B5EF4-FFF2-40B4-BE49-F238E27FC236}">
-                <a16:creationId xmlns:a16="http://schemas.microsoft.com/office/drawing/2014/main" id="{3B2F2B5F-F67D-478E-95A2-A4136A4283AB}"/>
+                <a16:creationId xmlns:a16="http://schemas.microsoft.com/office/drawing/2014/main" id="{0BE3CF57-C0F9-45EE-8ED3-FF1474E1E05C}"/>
               </a:ext>
             </a:extLst>
           </p:cNvPr>
@@ -6277,7 +6277,7 @@
             <a:hlinkClick r:id="rId2"/>
             <a:extLst>
               <a:ext uri="{FF2B5EF4-FFF2-40B4-BE49-F238E27FC236}">
-                <a16:creationId xmlns:a16="http://schemas.microsoft.com/office/drawing/2014/main" id="{4904F74A-99B9-4C3C-8149-FA1A05724020}"/>
+                <a16:creationId xmlns:a16="http://schemas.microsoft.com/office/drawing/2014/main" id="{C2002DD9-8327-4036-BA63-133F3C19EBFC}"/>
               </a:ext>
             </a:extLst>
           </p:cNvPr>
@@ -6314,7 +6314,7 @@
             <a:hlinkClick r:id="rId2"/>
             <a:extLst>
               <a:ext uri="{FF2B5EF4-FFF2-40B4-BE49-F238E27FC236}">
-                <a16:creationId xmlns:a16="http://schemas.microsoft.com/office/drawing/2014/main" id="{2C9B0E8F-089D-43B6-97AC-8B6247C26887}"/>
+                <a16:creationId xmlns:a16="http://schemas.microsoft.com/office/drawing/2014/main" id="{DF32F3C1-2762-45F8-B2D9-4CBC4F521963}"/>
               </a:ext>
             </a:extLst>
           </p:cNvPr>
@@ -6390,7 +6390,7 @@
           <p:cNvPr id="26" name="TextBox 25">
             <a:extLst>
               <a:ext uri="{FF2B5EF4-FFF2-40B4-BE49-F238E27FC236}">
-                <a16:creationId xmlns:a16="http://schemas.microsoft.com/office/drawing/2014/main" id="{AE991D9D-C33D-43B1-BD70-22893AEEE6D8}"/>
+                <a16:creationId xmlns:a16="http://schemas.microsoft.com/office/drawing/2014/main" id="{0B3CECA9-9D31-4C76-B89F-C69FCFFDC8F5}"/>
               </a:ext>
             </a:extLst>
           </p:cNvPr>
@@ -6430,7 +6430,7 @@
           <p:cNvPr id="27" name="TextBox 26">
             <a:extLst>
               <a:ext uri="{FF2B5EF4-FFF2-40B4-BE49-F238E27FC236}">
-                <a16:creationId xmlns:a16="http://schemas.microsoft.com/office/drawing/2014/main" id="{F5EC2620-D3F8-4010-A546-46A8A480F640}"/>
+                <a16:creationId xmlns:a16="http://schemas.microsoft.com/office/drawing/2014/main" id="{73C81065-CADE-43B9-BEAC-F804507FC8BD}"/>
               </a:ext>
             </a:extLst>
           </p:cNvPr>
@@ -6472,7 +6472,7 @@
             <a:hlinkClick r:id="rId2"/>
             <a:extLst>
               <a:ext uri="{FF2B5EF4-FFF2-40B4-BE49-F238E27FC236}">
-                <a16:creationId xmlns:a16="http://schemas.microsoft.com/office/drawing/2014/main" id="{DF80D9C7-56AF-4455-A7EA-61452EFFCF5E}"/>
+                <a16:creationId xmlns:a16="http://schemas.microsoft.com/office/drawing/2014/main" id="{61C0A547-0F52-4CA9-834E-C9E1900F954F}"/>
               </a:ext>
             </a:extLst>
           </p:cNvPr>
@@ -6549,7 +6549,7 @@
             <a:hlinkClick r:id="rId2"/>
             <a:extLst>
               <a:ext uri="{FF2B5EF4-FFF2-40B4-BE49-F238E27FC236}">
-                <a16:creationId xmlns:a16="http://schemas.microsoft.com/office/drawing/2014/main" id="{131402E3-02AE-4F8E-920C-48A9A6B0A73C}"/>
+                <a16:creationId xmlns:a16="http://schemas.microsoft.com/office/drawing/2014/main" id="{4C6368E0-8923-49A9-96F1-A56DA0B82F64}"/>
               </a:ext>
             </a:extLst>
           </p:cNvPr>
@@ -6604,7 +6604,7 @@
             <a:hlinkClick r:id="rId2"/>
             <a:extLst>
               <a:ext uri="{FF2B5EF4-FFF2-40B4-BE49-F238E27FC236}">
-                <a16:creationId xmlns:a16="http://schemas.microsoft.com/office/drawing/2014/main" id="{89A202EC-F931-4B3B-BA89-D1E59D6B40FD}"/>
+                <a16:creationId xmlns:a16="http://schemas.microsoft.com/office/drawing/2014/main" id="{DBB92221-E11D-4D96-BB6E-0BD702DC6CF3}"/>
               </a:ext>
             </a:extLst>
           </p:cNvPr>
@@ -6641,7 +6641,7 @@
             <a:hlinkClick r:id="rId2"/>
             <a:extLst>
               <a:ext uri="{FF2B5EF4-FFF2-40B4-BE49-F238E27FC236}">
-                <a16:creationId xmlns:a16="http://schemas.microsoft.com/office/drawing/2014/main" id="{BEE78561-DD22-404B-8FB0-4B707EDEC5B6}"/>
+                <a16:creationId xmlns:a16="http://schemas.microsoft.com/office/drawing/2014/main" id="{A085BB02-AA64-4524-BE6E-05AB21C59294}"/>
               </a:ext>
             </a:extLst>
           </p:cNvPr>
@@ -6717,7 +6717,7 @@
           <p:cNvPr id="33" name="TextBox 32">
             <a:extLst>
               <a:ext uri="{FF2B5EF4-FFF2-40B4-BE49-F238E27FC236}">
-                <a16:creationId xmlns:a16="http://schemas.microsoft.com/office/drawing/2014/main" id="{2225541F-BB9D-45D3-AB38-F05038466496}"/>
+                <a16:creationId xmlns:a16="http://schemas.microsoft.com/office/drawing/2014/main" id="{44208B25-4FF1-452F-B36B-295FC66D3C72}"/>
               </a:ext>
             </a:extLst>
           </p:cNvPr>
@@ -6757,7 +6757,7 @@
           <p:cNvPr id="34" name="TextBox 33">
             <a:extLst>
               <a:ext uri="{FF2B5EF4-FFF2-40B4-BE49-F238E27FC236}">
-                <a16:creationId xmlns:a16="http://schemas.microsoft.com/office/drawing/2014/main" id="{05549C21-56BF-42D6-AB82-F9A7850E38C9}"/>
+                <a16:creationId xmlns:a16="http://schemas.microsoft.com/office/drawing/2014/main" id="{529CC0D6-F1E6-429E-97A5-6A28C4A9BE2C}"/>
               </a:ext>
             </a:extLst>
           </p:cNvPr>
@@ -6799,7 +6799,7 @@
             <a:hlinkClick r:id="rId2"/>
             <a:extLst>
               <a:ext uri="{FF2B5EF4-FFF2-40B4-BE49-F238E27FC236}">
-                <a16:creationId xmlns:a16="http://schemas.microsoft.com/office/drawing/2014/main" id="{3362C9D3-A626-45BE-AE66-73E201F17288}"/>
+                <a16:creationId xmlns:a16="http://schemas.microsoft.com/office/drawing/2014/main" id="{E0F91079-DF4A-4801-B166-0FC1FECCE46B}"/>
               </a:ext>
             </a:extLst>
           </p:cNvPr>
@@ -6875,7 +6875,7 @@
           <p:cNvPr id="36" name="Rectangle 35">
             <a:extLst>
               <a:ext uri="{FF2B5EF4-FFF2-40B4-BE49-F238E27FC236}">
-                <a16:creationId xmlns:a16="http://schemas.microsoft.com/office/drawing/2014/main" id="{1B2E12C4-4127-4259-9E1B-E01242DDEC0D}"/>
+                <a16:creationId xmlns:a16="http://schemas.microsoft.com/office/drawing/2014/main" id="{CE72D065-C7DE-4571-A4E1-A31F459750C2}"/>
               </a:ext>
             </a:extLst>
           </p:cNvPr>
@@ -6929,7 +6929,7 @@
           <p:cNvPr id="37" name="TextBox 36">
             <a:extLst>
               <a:ext uri="{FF2B5EF4-FFF2-40B4-BE49-F238E27FC236}">
-                <a16:creationId xmlns:a16="http://schemas.microsoft.com/office/drawing/2014/main" id="{0741B213-D7B5-4A9A-8905-F6E23631FACA}"/>
+                <a16:creationId xmlns:a16="http://schemas.microsoft.com/office/drawing/2014/main" id="{1CC6D52F-0B4D-4BA3-980C-357A433FA220}"/>
               </a:ext>
             </a:extLst>
           </p:cNvPr>
@@ -6971,7 +6971,7 @@
             <a:hlinkClick r:id="rId2"/>
             <a:extLst>
               <a:ext uri="{FF2B5EF4-FFF2-40B4-BE49-F238E27FC236}">
-                <a16:creationId xmlns:a16="http://schemas.microsoft.com/office/drawing/2014/main" id="{1A9A9A4D-13CD-44E2-9A9F-0B44E3EEEC6B}"/>
+                <a16:creationId xmlns:a16="http://schemas.microsoft.com/office/drawing/2014/main" id="{D97E9DDD-7746-4E69-94AD-365976050917}"/>
               </a:ext>
             </a:extLst>
           </p:cNvPr>
@@ -7045,7 +7045,7 @@
     </p:spTree>
     <p:extLst>
       <p:ext uri="{BB962C8B-B14F-4D97-AF65-F5344CB8AC3E}">
-        <p14:creationId xmlns:p14="http://schemas.microsoft.com/office/powerpoint/2010/main" val="494701118"/>
+        <p14:creationId xmlns:p14="http://schemas.microsoft.com/office/powerpoint/2010/main" val="1521836299"/>
       </p:ext>
     </p:extLst>
   </p:cSld>

</xml_diff>